<commit_message>
Improve comparison visual coherence
</commit_message>
<xml_diff>
--- a/artifacts/mdpr-vs-skill/mdpr-skill-from-actual-md-run.pptx
+++ b/artifacts/mdpr-vs-skill/mdpr-skill-from-actual-md-run.pptx
@@ -6872,8 +6872,8 @@
         </p:nvSpPr>
         <p:spPr>
           <a:xfrm>
-            <a:off x="749808" y="3858768"/>
-            <a:ext cx="4892040" cy="1664208"/>
+            <a:off x="749808" y="3730752"/>
+            <a:ext cx="4892040" cy="1874519"/>
           </a:xfrm>
           <a:prstGeom prst="roundRect">
             <a:avLst/>
@@ -6917,7 +6917,7 @@
         </p:nvSpPr>
         <p:spPr>
           <a:xfrm>
-            <a:off x="914400" y="4023359"/>
+            <a:off x="914400" y="3895344"/>
             <a:ext cx="285292" cy="368503"/>
           </a:xfrm>
           <a:prstGeom prst="roundRect">
@@ -6962,7 +6962,7 @@
         </p:nvSpPr>
         <p:spPr>
           <a:xfrm>
-            <a:off x="985723" y="4118457"/>
+            <a:off x="985723" y="3990441"/>
             <a:ext cx="148590" cy="20802"/>
           </a:xfrm>
           <a:prstGeom prst="rect">
@@ -7007,7 +7007,7 @@
         </p:nvSpPr>
         <p:spPr>
           <a:xfrm>
-            <a:off x="985723" y="4195724"/>
+            <a:off x="985723" y="4067708"/>
             <a:ext cx="148590" cy="20802"/>
           </a:xfrm>
           <a:prstGeom prst="rect">
@@ -7052,7 +7052,7 @@
         </p:nvSpPr>
         <p:spPr>
           <a:xfrm>
-            <a:off x="985723" y="4272991"/>
+            <a:off x="985723" y="4144975"/>
             <a:ext cx="148590" cy="20802"/>
           </a:xfrm>
           <a:prstGeom prst="rect">
@@ -7097,7 +7097,7 @@
         </p:nvSpPr>
         <p:spPr>
           <a:xfrm>
-            <a:off x="1554480" y="4041648"/>
+            <a:off x="1554480" y="3913632"/>
             <a:ext cx="3904487" cy="347472"/>
           </a:xfrm>
           <a:prstGeom prst="rect">
@@ -7130,7 +7130,7 @@
         </p:nvSpPr>
         <p:spPr>
           <a:xfrm>
-            <a:off x="1554480" y="4498848"/>
+            <a:off x="1554480" y="4370832"/>
             <a:ext cx="3904487" cy="310896"/>
           </a:xfrm>
           <a:prstGeom prst="rect">
@@ -7163,7 +7163,7 @@
         </p:nvSpPr>
         <p:spPr>
           <a:xfrm>
-            <a:off x="1554480" y="4882896"/>
+            <a:off x="1554480" y="4754880"/>
             <a:ext cx="3904487" cy="310896"/>
           </a:xfrm>
           <a:prstGeom prst="rect">
@@ -7196,7 +7196,7 @@
         </p:nvSpPr>
         <p:spPr>
           <a:xfrm>
-            <a:off x="1554480" y="5266944"/>
+            <a:off x="1554480" y="5138928"/>
             <a:ext cx="3904487" cy="310896"/>
           </a:xfrm>
           <a:prstGeom prst="rect">
@@ -7229,8 +7229,8 @@
         </p:nvSpPr>
         <p:spPr>
           <a:xfrm>
-            <a:off x="6144768" y="3858768"/>
-            <a:ext cx="4892040" cy="1664208"/>
+            <a:off x="6144768" y="3730752"/>
+            <a:ext cx="4892040" cy="1874519"/>
           </a:xfrm>
           <a:prstGeom prst="roundRect">
             <a:avLst/>
@@ -7274,7 +7274,7 @@
         </p:nvSpPr>
         <p:spPr>
           <a:xfrm>
-            <a:off x="6452006" y="4023359"/>
+            <a:off x="6452006" y="3895344"/>
             <a:ext cx="35661" cy="344728"/>
           </a:xfrm>
           <a:prstGeom prst="rect">
@@ -7319,7 +7319,7 @@
         </p:nvSpPr>
         <p:spPr>
           <a:xfrm>
-            <a:off x="6309359" y="4166006"/>
+            <a:off x="6309359" y="4037990"/>
             <a:ext cx="344728" cy="35661"/>
           </a:xfrm>
           <a:prstGeom prst="rect">
@@ -7364,7 +7364,7 @@
         </p:nvSpPr>
         <p:spPr>
           <a:xfrm>
-            <a:off x="6570878" y="4284878"/>
+            <a:off x="6570878" y="4156862"/>
             <a:ext cx="59436" cy="59436"/>
           </a:xfrm>
           <a:prstGeom prst="ellipse">
@@ -7409,7 +7409,7 @@
         </p:nvSpPr>
         <p:spPr>
           <a:xfrm>
-            <a:off x="6949440" y="4041648"/>
+            <a:off x="6949440" y="3913632"/>
             <a:ext cx="3904487" cy="347472"/>
           </a:xfrm>
           <a:prstGeom prst="rect">
@@ -7442,7 +7442,7 @@
         </p:nvSpPr>
         <p:spPr>
           <a:xfrm>
-            <a:off x="6949440" y="4498848"/>
+            <a:off x="6949440" y="4370832"/>
             <a:ext cx="3904487" cy="310896"/>
           </a:xfrm>
           <a:prstGeom prst="rect">
@@ -7475,7 +7475,7 @@
         </p:nvSpPr>
         <p:spPr>
           <a:xfrm>
-            <a:off x="6949440" y="4882896"/>
+            <a:off x="6949440" y="4754880"/>
             <a:ext cx="3904487" cy="310896"/>
           </a:xfrm>
           <a:prstGeom prst="rect">
@@ -7508,7 +7508,7 @@
         </p:nvSpPr>
         <p:spPr>
           <a:xfrm>
-            <a:off x="6949440" y="5266944"/>
+            <a:off x="6949440" y="5138928"/>
             <a:ext cx="3904487" cy="310896"/>
           </a:xfrm>
           <a:prstGeom prst="rect">
@@ -13570,31 +13570,64 @@
                   <a:srgbClr val="111827"/>
                 </a:solidFill>
               </a:rPr>
-              <a:t>Visual suggestions remain optional and semantic</a:t>
-            </a:r>
-          </a:p>
-        </p:txBody>
-      </p:sp>
-      <p:sp>
-        <p:nvSpPr>
-          <p:cNvPr id="4" name="body_panel"/>
+              <a:t>Suggestions stop before geometry</a:t>
+            </a:r>
+          </a:p>
+        </p:txBody>
+      </p:sp>
+      <p:sp>
+        <p:nvSpPr>
+          <p:cNvPr id="4" name="suggestion_heading"/>
+          <p:cNvSpPr txBox="1"/>
+          <p:nvPr/>
+        </p:nvSpPr>
+        <p:spPr>
+          <a:xfrm>
+            <a:off x="804672" y="1417320"/>
+            <a:ext cx="4800600" cy="411480"/>
+          </a:xfrm>
+          <a:prstGeom prst="rect">
+            <a:avLst/>
+          </a:prstGeom>
+          <a:noFill/>
+        </p:spPr>
+        <p:txBody>
+          <a:bodyPr wrap="square" anchor="ctr" lIns="0" rIns="0" tIns="0" bIns="0">
+            <a:spAutoFit/>
+          </a:bodyPr>
+          <a:lstStyle/>
+          <a:p>
+            <a:r>
+              <a:rPr sz="2000" b="1">
+                <a:solidFill>
+                  <a:srgbClr val="0F766E"/>
+                </a:solidFill>
+              </a:rPr>
+              <a:t>mdpr-skill may suggest</a:t>
+            </a:r>
+          </a:p>
+        </p:txBody>
+      </p:sp>
+      <p:sp>
+        <p:nvSpPr>
+          <p:cNvPr id="5" name="suggestion_0_mark"/>
           <p:cNvSpPr/>
           <p:nvPr/>
         </p:nvSpPr>
         <p:spPr>
           <a:xfrm>
-            <a:off x="822960" y="1536192"/>
-            <a:ext cx="6400800" cy="3401568"/>
-          </a:xfrm>
-          <a:prstGeom prst="roundRect">
-            <a:avLst/>
-          </a:prstGeom>
-          <a:solidFill>
-            <a:srgbClr val="FFFDF8"/>
+            <a:off x="822960" y="2103120"/>
+            <a:ext cx="164592" cy="530352"/>
+          </a:xfrm>
+          <a:prstGeom prst="rect">
+            <a:avLst/>
+          </a:prstGeom>
+          <a:solidFill>
+            <a:srgbClr val="0F766E"/>
           </a:solidFill>
           <a:ln>
             <a:solidFill>
-              <a:srgbClr val="D7CDBD"/>
+              <a:srgbClr val="0F766E"/>
             </a:solidFill>
           </a:ln>
         </p:spPr>
@@ -13622,14 +13655,14 @@
       </p:sp>
       <p:sp>
         <p:nvSpPr>
-          <p:cNvPr id="5" name="body_heading"/>
+          <p:cNvPr id="6" name="suggestion_0_label"/>
           <p:cNvSpPr txBox="1"/>
           <p:nvPr/>
         </p:nvSpPr>
         <p:spPr>
           <a:xfrm>
-            <a:off x="1115568" y="1828800"/>
-            <a:ext cx="5303520" cy="310896"/>
+            <a:off x="1170432" y="2057400"/>
+            <a:ext cx="1143000" cy="274320"/>
           </a:xfrm>
           <a:prstGeom prst="rect">
             <a:avLst/>
@@ -13643,26 +13676,26 @@
           <a:lstStyle/>
           <a:p>
             <a:r>
-              <a:rPr sz="1800" b="1">
+              <a:rPr sz="1600" b="1">
                 <a:solidFill>
                   <a:srgbClr val="111827"/>
                 </a:solidFill>
               </a:rPr>
-              <a:t>Current skill behavior</a:t>
-            </a:r>
-          </a:p>
-        </p:txBody>
-      </p:sp>
-      <p:sp>
-        <p:nvSpPr>
-          <p:cNvPr id="6" name="icon_bullet_0"/>
+              <a:t>PLACEMENT</a:t>
+            </a:r>
+          </a:p>
+        </p:txBody>
+      </p:sp>
+      <p:sp>
+        <p:nvSpPr>
+          <p:cNvPr id="7" name="suggestion_0_body"/>
           <p:cNvSpPr txBox="1"/>
           <p:nvPr/>
         </p:nvSpPr>
         <p:spPr>
           <a:xfrm>
-            <a:off x="1170432" y="2331720"/>
-            <a:ext cx="5303520" cy="329184"/>
+            <a:off x="2359152" y="2039112"/>
+            <a:ext cx="3246120" cy="621792"/>
           </a:xfrm>
           <a:prstGeom prst="rect">
             <a:avLst/>
@@ -13681,163 +13714,31 @@
                   <a:srgbClr val="5F6B7A"/>
                 </a:solidFill>
               </a:rPr>
-              <a:t>- Reserve an aside/corner region, not a primary region.</a:t>
-            </a:r>
-          </a:p>
-        </p:txBody>
-      </p:sp>
-      <p:sp>
-        <p:nvSpPr>
-          <p:cNvPr id="7" name="icon_bullet_1"/>
-          <p:cNvSpPr txBox="1"/>
-          <p:nvPr/>
-        </p:nvSpPr>
-        <p:spPr>
-          <a:xfrm>
-            <a:off x="1170432" y="2770632"/>
-            <a:ext cx="5303520" cy="329184"/>
-          </a:xfrm>
-          <a:prstGeom prst="rect">
-            <a:avLst/>
-          </a:prstGeom>
-          <a:noFill/>
-        </p:spPr>
-        <p:txBody>
-          <a:bodyPr wrap="square" anchor="ctr" lIns="0" rIns="0" tIns="0" bIns="0">
-            <a:spAutoFit/>
-          </a:bodyPr>
-          <a:lstStyle/>
-          <a:p>
-            <a:r>
-              <a:rPr sz="1600" b="0">
-                <a:solidFill>
-                  <a:srgbClr val="5F6B7A"/>
-                </a:solidFill>
-              </a:rPr>
-              <a:t>- Use one black or white icon.</a:t>
-            </a:r>
-          </a:p>
-        </p:txBody>
-      </p:sp>
-      <p:sp>
-        <p:nvSpPr>
-          <p:cNvPr id="8" name="icon_bullet_2"/>
-          <p:cNvSpPr txBox="1"/>
-          <p:nvPr/>
-        </p:nvSpPr>
-        <p:spPr>
-          <a:xfrm>
-            <a:off x="1170432" y="3209544"/>
-            <a:ext cx="5303520" cy="329184"/>
-          </a:xfrm>
-          <a:prstGeom prst="rect">
-            <a:avLst/>
-          </a:prstGeom>
-          <a:noFill/>
-        </p:spPr>
-        <p:txBody>
-          <a:bodyPr wrap="square" anchor="ctr" lIns="0" rIns="0" tIns="0" bIns="0">
-            <a:spAutoFit/>
-          </a:bodyPr>
-          <a:lstStyle/>
-          <a:p>
-            <a:r>
-              <a:rPr sz="1600" b="0">
-                <a:solidFill>
-                  <a:srgbClr val="5F6B7A"/>
-                </a:solidFill>
-              </a:rPr>
-              <a:t>- Prefer PowerPoint built-in icons.</a:t>
-            </a:r>
-          </a:p>
-        </p:txBody>
-      </p:sp>
-      <p:sp>
-        <p:nvSpPr>
-          <p:cNvPr id="9" name="icon_bullet_3"/>
-          <p:cNvSpPr txBox="1"/>
-          <p:nvPr/>
-        </p:nvSpPr>
-        <p:spPr>
-          <a:xfrm>
-            <a:off x="1170432" y="3648456"/>
-            <a:ext cx="5303520" cy="329184"/>
-          </a:xfrm>
-          <a:prstGeom prst="rect">
-            <a:avLst/>
-          </a:prstGeom>
-          <a:noFill/>
-        </p:spPr>
-        <p:txBody>
-          <a:bodyPr wrap="square" anchor="ctr" lIns="0" rIns="0" tIns="0" bIns="0">
-            <a:spAutoFit/>
-          </a:bodyPr>
-          <a:lstStyle/>
-          <a:p>
-            <a:r>
-              <a:rPr sz="1600" b="0">
-                <a:solidFill>
-                  <a:srgbClr val="5F6B7A"/>
-                </a:solidFill>
-              </a:rPr>
-              <a:t>- Allow free SVG only with license record.</a:t>
-            </a:r>
-          </a:p>
-        </p:txBody>
-      </p:sp>
-      <p:sp>
-        <p:nvSpPr>
-          <p:cNvPr id="10" name="icon_bullet_4"/>
-          <p:cNvSpPr txBox="1"/>
-          <p:nvPr/>
-        </p:nvSpPr>
-        <p:spPr>
-          <a:xfrm>
-            <a:off x="1170432" y="4087368"/>
-            <a:ext cx="5303520" cy="329184"/>
-          </a:xfrm>
-          <a:prstGeom prst="rect">
-            <a:avLst/>
-          </a:prstGeom>
-          <a:noFill/>
-        </p:spPr>
-        <p:txBody>
-          <a:bodyPr wrap="square" anchor="ctr" lIns="0" rIns="0" tIns="0" bIns="0">
-            <a:spAutoFit/>
-          </a:bodyPr>
-          <a:lstStyle/>
-          <a:p>
-            <a:r>
-              <a:rPr sz="1600" b="0">
-                <a:solidFill>
-                  <a:srgbClr val="5F6B7A"/>
-                </a:solidFill>
-              </a:rPr>
-              <a:t>- Validate icon center against text midpoint.</a:t>
-            </a:r>
-          </a:p>
-        </p:txBody>
-      </p:sp>
-      <p:sp>
-        <p:nvSpPr>
-          <p:cNvPr id="11" name="icon_slot"/>
+              <a:t>Reserve an aside or corner region.</a:t>
+            </a:r>
+          </a:p>
+        </p:txBody>
+      </p:sp>
+      <p:sp>
+        <p:nvSpPr>
+          <p:cNvPr id="8" name="suggestion_1_mark"/>
           <p:cNvSpPr/>
           <p:nvPr/>
         </p:nvSpPr>
         <p:spPr>
           <a:xfrm>
-            <a:off x="7818120" y="1965960"/>
-            <a:ext cx="2212848" cy="2212848"/>
-          </a:xfrm>
-          <a:prstGeom prst="roundRect">
-            <a:avLst/>
-          </a:prstGeom>
-          <a:solidFill>
-            <a:srgbClr val="EAF7F3"/>
+            <a:off x="822960" y="3182111"/>
+            <a:ext cx="164592" cy="530352"/>
+          </a:xfrm>
+          <a:prstGeom prst="rect">
+            <a:avLst/>
+          </a:prstGeom>
+          <a:solidFill>
+            <a:srgbClr val="0F766E"/>
           </a:solidFill>
           <a:ln>
             <a:solidFill>
-              <a:srgbClr val="D7CDBD"/>
+              <a:srgbClr val="0F766E"/>
             </a:solidFill>
           </a:ln>
         </p:spPr>
@@ -13865,24 +13766,90 @@
       </p:sp>
       <p:sp>
         <p:nvSpPr>
-          <p:cNvPr id="12" name="aside_icon_v"/>
+          <p:cNvPr id="9" name="suggestion_1_label"/>
+          <p:cNvSpPr txBox="1"/>
+          <p:nvPr/>
+        </p:nvSpPr>
+        <p:spPr>
+          <a:xfrm>
+            <a:off x="1170432" y="3136391"/>
+            <a:ext cx="1143000" cy="274320"/>
+          </a:xfrm>
+          <a:prstGeom prst="rect">
+            <a:avLst/>
+          </a:prstGeom>
+          <a:noFill/>
+        </p:spPr>
+        <p:txBody>
+          <a:bodyPr wrap="square" anchor="ctr" lIns="0" rIns="0" tIns="0" bIns="0">
+            <a:spAutoFit/>
+          </a:bodyPr>
+          <a:lstStyle/>
+          <a:p>
+            <a:r>
+              <a:rPr sz="1600" b="1">
+                <a:solidFill>
+                  <a:srgbClr val="111827"/>
+                </a:solidFill>
+              </a:rPr>
+              <a:t>SOURCE</a:t>
+            </a:r>
+          </a:p>
+        </p:txBody>
+      </p:sp>
+      <p:sp>
+        <p:nvSpPr>
+          <p:cNvPr id="10" name="suggestion_1_body"/>
+          <p:cNvSpPr txBox="1"/>
+          <p:nvPr/>
+        </p:nvSpPr>
+        <p:spPr>
+          <a:xfrm>
+            <a:off x="2359152" y="3118103"/>
+            <a:ext cx="3246120" cy="621792"/>
+          </a:xfrm>
+          <a:prstGeom prst="rect">
+            <a:avLst/>
+          </a:prstGeom>
+          <a:noFill/>
+        </p:spPr>
+        <p:txBody>
+          <a:bodyPr wrap="square" anchor="ctr" lIns="0" rIns="0" tIns="0" bIns="0">
+            <a:spAutoFit/>
+          </a:bodyPr>
+          <a:lstStyle/>
+          <a:p>
+            <a:r>
+              <a:rPr sz="1600" b="0">
+                <a:solidFill>
+                  <a:srgbClr val="5F6B7A"/>
+                </a:solidFill>
+              </a:rPr>
+              <a:t>Use one licensed monochrome icon.</a:t>
+            </a:r>
+          </a:p>
+        </p:txBody>
+      </p:sp>
+      <p:sp>
+        <p:nvSpPr>
+          <p:cNvPr id="11" name="suggestion_2_mark"/>
           <p:cNvSpPr/>
           <p:nvPr/>
         </p:nvSpPr>
         <p:spPr>
           <a:xfrm>
-            <a:off x="8745321" y="2487168"/>
-            <a:ext cx="87782" cy="848563"/>
-          </a:xfrm>
-          <a:prstGeom prst="rect">
-            <a:avLst/>
-          </a:prstGeom>
-          <a:solidFill>
-            <a:srgbClr val="111827"/>
+            <a:off x="822960" y="4261103"/>
+            <a:ext cx="164592" cy="530352"/>
+          </a:xfrm>
+          <a:prstGeom prst="rect">
+            <a:avLst/>
+          </a:prstGeom>
+          <a:solidFill>
+            <a:srgbClr val="0F766E"/>
           </a:solidFill>
           <a:ln>
             <a:solidFill>
-              <a:srgbClr val="111827"/>
+              <a:srgbClr val="0F766E"/>
             </a:solidFill>
           </a:ln>
         </p:spPr>
@@ -13910,24 +13877,90 @@
       </p:sp>
       <p:sp>
         <p:nvSpPr>
-          <p:cNvPr id="13" name="aside_icon_h"/>
+          <p:cNvPr id="12" name="suggestion_2_label"/>
+          <p:cNvSpPr txBox="1"/>
+          <p:nvPr/>
+        </p:nvSpPr>
+        <p:spPr>
+          <a:xfrm>
+            <a:off x="1170432" y="4215383"/>
+            <a:ext cx="1143000" cy="274320"/>
+          </a:xfrm>
+          <a:prstGeom prst="rect">
+            <a:avLst/>
+          </a:prstGeom>
+          <a:noFill/>
+        </p:spPr>
+        <p:txBody>
+          <a:bodyPr wrap="square" anchor="ctr" lIns="0" rIns="0" tIns="0" bIns="0">
+            <a:spAutoFit/>
+          </a:bodyPr>
+          <a:lstStyle/>
+          <a:p>
+            <a:r>
+              <a:rPr sz="1600" b="1">
+                <a:solidFill>
+                  <a:srgbClr val="111827"/>
+                </a:solidFill>
+              </a:rPr>
+              <a:t>CHECK</a:t>
+            </a:r>
+          </a:p>
+        </p:txBody>
+      </p:sp>
+      <p:sp>
+        <p:nvSpPr>
+          <p:cNvPr id="13" name="suggestion_2_body"/>
+          <p:cNvSpPr txBox="1"/>
+          <p:nvPr/>
+        </p:nvSpPr>
+        <p:spPr>
+          <a:xfrm>
+            <a:off x="2359152" y="4197096"/>
+            <a:ext cx="3246120" cy="621792"/>
+          </a:xfrm>
+          <a:prstGeom prst="rect">
+            <a:avLst/>
+          </a:prstGeom>
+          <a:noFill/>
+        </p:spPr>
+        <p:txBody>
+          <a:bodyPr wrap="square" anchor="ctr" lIns="0" rIns="0" tIns="0" bIns="0">
+            <a:spAutoFit/>
+          </a:bodyPr>
+          <a:lstStyle/>
+          <a:p>
+            <a:r>
+              <a:rPr sz="1600" b="0">
+                <a:solidFill>
+                  <a:srgbClr val="5F6B7A"/>
+                </a:solidFill>
+              </a:rPr>
+              <a:t>Compare visual center with the text midpoint.</a:t>
+            </a:r>
+          </a:p>
+        </p:txBody>
+      </p:sp>
+      <p:sp>
+        <p:nvSpPr>
+          <p:cNvPr id="14" name="runtime_field"/>
           <p:cNvSpPr/>
           <p:nvPr/>
         </p:nvSpPr>
         <p:spPr>
           <a:xfrm>
-            <a:off x="8394192" y="2838297"/>
-            <a:ext cx="848563" cy="87782"/>
-          </a:xfrm>
-          <a:prstGeom prst="rect">
-            <a:avLst/>
-          </a:prstGeom>
-          <a:solidFill>
-            <a:srgbClr val="111827"/>
+            <a:off x="6144768" y="1298448"/>
+            <a:ext cx="5394960" cy="4526280"/>
+          </a:xfrm>
+          <a:prstGeom prst="rect">
+            <a:avLst/>
+          </a:prstGeom>
+          <a:solidFill>
+            <a:srgbClr val="EAF7F3"/>
           </a:solidFill>
           <a:ln>
             <a:solidFill>
-              <a:srgbClr val="111827"/>
+              <a:srgbClr val="EAF7F3"/>
             </a:solidFill>
           </a:ln>
         </p:spPr>
@@ -13955,46 +13988,331 @@
       </p:sp>
       <p:sp>
         <p:nvSpPr>
-          <p:cNvPr id="14" name="aside_icon_dot"/>
-          <p:cNvSpPr/>
-          <p:nvPr/>
-        </p:nvSpPr>
-        <p:spPr>
-          <a:xfrm>
-            <a:off x="9037929" y="3130905"/>
-            <a:ext cx="146304" cy="146304"/>
-          </a:xfrm>
-          <a:prstGeom prst="ellipse">
-            <a:avLst/>
-          </a:prstGeom>
-          <a:solidFill>
-            <a:srgbClr val="111827"/>
-          </a:solidFill>
-          <a:ln>
-            <a:solidFill>
-              <a:srgbClr val="111827"/>
-            </a:solidFill>
-          </a:ln>
-        </p:spPr>
-        <p:style>
-          <a:lnRef idx="1">
-            <a:schemeClr val="accent1"/>
-          </a:lnRef>
-          <a:fillRef idx="3">
-            <a:schemeClr val="accent1"/>
-          </a:fillRef>
-          <a:effectRef idx="2">
-            <a:schemeClr val="accent1"/>
-          </a:effectRef>
-          <a:fontRef idx="minor">
-            <a:schemeClr val="lt1"/>
-          </a:fontRef>
-        </p:style>
-        <p:txBody>
-          <a:bodyPr rtlCol="0" anchor="ctr"/>
-          <a:lstStyle/>
-          <a:p>
-            <a:pPr algn="ctr"/>
+          <p:cNvPr id="15" name="runtime_heading"/>
+          <p:cNvSpPr txBox="1"/>
+          <p:nvPr/>
+        </p:nvSpPr>
+        <p:spPr>
+          <a:xfrm>
+            <a:off x="6565392" y="1417320"/>
+            <a:ext cx="4434840" cy="411480"/>
+          </a:xfrm>
+          <a:prstGeom prst="rect">
+            <a:avLst/>
+          </a:prstGeom>
+          <a:noFill/>
+        </p:spPr>
+        <p:txBody>
+          <a:bodyPr wrap="square" anchor="ctr" lIns="0" rIns="0" tIns="0" bIns="0">
+            <a:spAutoFit/>
+          </a:bodyPr>
+          <a:lstStyle/>
+          <a:p>
+            <a:r>
+              <a:rPr sz="2000" b="1">
+                <a:solidFill>
+                  <a:srgbClr val="7C3AED"/>
+                </a:solidFill>
+              </a:rPr>
+              <a:t>MDPR still decides</a:t>
+            </a:r>
+          </a:p>
+        </p:txBody>
+      </p:sp>
+      <p:sp>
+        <p:nvSpPr>
+          <p:cNvPr id="16" name="decision_0_num"/>
+          <p:cNvSpPr txBox="1"/>
+          <p:nvPr/>
+        </p:nvSpPr>
+        <p:spPr>
+          <a:xfrm>
+            <a:off x="6565392" y="2029968"/>
+            <a:ext cx="530352" cy="384048"/>
+          </a:xfrm>
+          <a:prstGeom prst="rect">
+            <a:avLst/>
+          </a:prstGeom>
+          <a:noFill/>
+        </p:spPr>
+        <p:txBody>
+          <a:bodyPr wrap="square" anchor="ctr" lIns="0" rIns="0" tIns="0" bIns="0">
+            <a:spAutoFit/>
+          </a:bodyPr>
+          <a:lstStyle/>
+          <a:p>
+            <a:r>
+              <a:rPr sz="1800" b="1">
+                <a:solidFill>
+                  <a:srgbClr val="7C3AED"/>
+                </a:solidFill>
+              </a:rPr>
+              <a:t>01</a:t>
+            </a:r>
+          </a:p>
+        </p:txBody>
+      </p:sp>
+      <p:sp>
+        <p:nvSpPr>
+          <p:cNvPr id="17" name="decision_0_title"/>
+          <p:cNvSpPr txBox="1"/>
+          <p:nvPr/>
+        </p:nvSpPr>
+        <p:spPr>
+          <a:xfrm>
+            <a:off x="7242048" y="2029968"/>
+            <a:ext cx="3566160" cy="310896"/>
+          </a:xfrm>
+          <a:prstGeom prst="rect">
+            <a:avLst/>
+          </a:prstGeom>
+          <a:noFill/>
+        </p:spPr>
+        <p:txBody>
+          <a:bodyPr wrap="square" anchor="ctr" lIns="0" rIns="0" tIns="0" bIns="0">
+            <a:spAutoFit/>
+          </a:bodyPr>
+          <a:lstStyle/>
+          <a:p>
+            <a:r>
+              <a:rPr sz="1800" b="1">
+                <a:solidFill>
+                  <a:srgbClr val="111827"/>
+                </a:solidFill>
+              </a:rPr>
+              <a:t>Exact geometry</a:t>
+            </a:r>
+          </a:p>
+        </p:txBody>
+      </p:sp>
+      <p:sp>
+        <p:nvSpPr>
+          <p:cNvPr id="18" name="decision_0_body"/>
+          <p:cNvSpPr txBox="1"/>
+          <p:nvPr/>
+        </p:nvSpPr>
+        <p:spPr>
+          <a:xfrm>
+            <a:off x="7242048" y="2414016"/>
+            <a:ext cx="3566160" cy="310896"/>
+          </a:xfrm>
+          <a:prstGeom prst="rect">
+            <a:avLst/>
+          </a:prstGeom>
+          <a:noFill/>
+        </p:spPr>
+        <p:txBody>
+          <a:bodyPr wrap="square" anchor="ctr" lIns="0" rIns="0" tIns="0" bIns="0">
+            <a:spAutoFit/>
+          </a:bodyPr>
+          <a:lstStyle/>
+          <a:p>
+            <a:r>
+              <a:rPr sz="1600" b="0">
+                <a:solidFill>
+                  <a:srgbClr val="5F6B7A"/>
+                </a:solidFill>
+              </a:rPr>
+              <a:t>regions and coordinates</a:t>
+            </a:r>
+          </a:p>
+        </p:txBody>
+      </p:sp>
+      <p:sp>
+        <p:nvSpPr>
+          <p:cNvPr id="19" name="decision_1_num"/>
+          <p:cNvSpPr txBox="1"/>
+          <p:nvPr/>
+        </p:nvSpPr>
+        <p:spPr>
+          <a:xfrm>
+            <a:off x="6565392" y="3127248"/>
+            <a:ext cx="530352" cy="384048"/>
+          </a:xfrm>
+          <a:prstGeom prst="rect">
+            <a:avLst/>
+          </a:prstGeom>
+          <a:noFill/>
+        </p:spPr>
+        <p:txBody>
+          <a:bodyPr wrap="square" anchor="ctr" lIns="0" rIns="0" tIns="0" bIns="0">
+            <a:spAutoFit/>
+          </a:bodyPr>
+          <a:lstStyle/>
+          <a:p>
+            <a:r>
+              <a:rPr sz="1800" b="1">
+                <a:solidFill>
+                  <a:srgbClr val="7C3AED"/>
+                </a:solidFill>
+              </a:rPr>
+              <a:t>02</a:t>
+            </a:r>
+          </a:p>
+        </p:txBody>
+      </p:sp>
+      <p:sp>
+        <p:nvSpPr>
+          <p:cNvPr id="20" name="decision_1_title"/>
+          <p:cNvSpPr txBox="1"/>
+          <p:nvPr/>
+        </p:nvSpPr>
+        <p:spPr>
+          <a:xfrm>
+            <a:off x="7242048" y="3127248"/>
+            <a:ext cx="3566160" cy="310896"/>
+          </a:xfrm>
+          <a:prstGeom prst="rect">
+            <a:avLst/>
+          </a:prstGeom>
+          <a:noFill/>
+        </p:spPr>
+        <p:txBody>
+          <a:bodyPr wrap="square" anchor="ctr" lIns="0" rIns="0" tIns="0" bIns="0">
+            <a:spAutoFit/>
+          </a:bodyPr>
+          <a:lstStyle/>
+          <a:p>
+            <a:r>
+              <a:rPr sz="1800" b="1">
+                <a:solidFill>
+                  <a:srgbClr val="111827"/>
+                </a:solidFill>
+              </a:rPr>
+              <a:t>Typography</a:t>
+            </a:r>
+          </a:p>
+        </p:txBody>
+      </p:sp>
+      <p:sp>
+        <p:nvSpPr>
+          <p:cNvPr id="21" name="decision_1_body"/>
+          <p:cNvSpPr txBox="1"/>
+          <p:nvPr/>
+        </p:nvSpPr>
+        <p:spPr>
+          <a:xfrm>
+            <a:off x="7242048" y="3511296"/>
+            <a:ext cx="3566160" cy="310896"/>
+          </a:xfrm>
+          <a:prstGeom prst="rect">
+            <a:avLst/>
+          </a:prstGeom>
+          <a:noFill/>
+        </p:spPr>
+        <p:txBody>
+          <a:bodyPr wrap="square" anchor="ctr" lIns="0" rIns="0" tIns="0" bIns="0">
+            <a:spAutoFit/>
+          </a:bodyPr>
+          <a:lstStyle/>
+          <a:p>
+            <a:r>
+              <a:rPr sz="1600" b="0">
+                <a:solidFill>
+                  <a:srgbClr val="5F6B7A"/>
+                </a:solidFill>
+              </a:rPr>
+              <a:t>font family, size, and wrapping</a:t>
+            </a:r>
+          </a:p>
+        </p:txBody>
+      </p:sp>
+      <p:sp>
+        <p:nvSpPr>
+          <p:cNvPr id="22" name="decision_2_num"/>
+          <p:cNvSpPr txBox="1"/>
+          <p:nvPr/>
+        </p:nvSpPr>
+        <p:spPr>
+          <a:xfrm>
+            <a:off x="6565392" y="4224528"/>
+            <a:ext cx="530352" cy="384048"/>
+          </a:xfrm>
+          <a:prstGeom prst="rect">
+            <a:avLst/>
+          </a:prstGeom>
+          <a:noFill/>
+        </p:spPr>
+        <p:txBody>
+          <a:bodyPr wrap="square" anchor="ctr" lIns="0" rIns="0" tIns="0" bIns="0">
+            <a:spAutoFit/>
+          </a:bodyPr>
+          <a:lstStyle/>
+          <a:p>
+            <a:r>
+              <a:rPr sz="1800" b="1">
+                <a:solidFill>
+                  <a:srgbClr val="7C3AED"/>
+                </a:solidFill>
+              </a:rPr>
+              <a:t>03</a:t>
+            </a:r>
+          </a:p>
+        </p:txBody>
+      </p:sp>
+      <p:sp>
+        <p:nvSpPr>
+          <p:cNvPr id="23" name="decision_2_title"/>
+          <p:cNvSpPr txBox="1"/>
+          <p:nvPr/>
+        </p:nvSpPr>
+        <p:spPr>
+          <a:xfrm>
+            <a:off x="7242048" y="4224528"/>
+            <a:ext cx="3566160" cy="310896"/>
+          </a:xfrm>
+          <a:prstGeom prst="rect">
+            <a:avLst/>
+          </a:prstGeom>
+          <a:noFill/>
+        </p:spPr>
+        <p:txBody>
+          <a:bodyPr wrap="square" anchor="ctr" lIns="0" rIns="0" tIns="0" bIns="0">
+            <a:spAutoFit/>
+          </a:bodyPr>
+          <a:lstStyle/>
+          <a:p>
+            <a:r>
+              <a:rPr sz="1800" b="1">
+                <a:solidFill>
+                  <a:srgbClr val="111827"/>
+                </a:solidFill>
+              </a:rPr>
+              <a:t>Pass or fail</a:t>
+            </a:r>
+          </a:p>
+        </p:txBody>
+      </p:sp>
+      <p:sp>
+        <p:nvSpPr>
+          <p:cNvPr id="24" name="decision_2_body"/>
+          <p:cNvSpPr txBox="1"/>
+          <p:nvPr/>
+        </p:nvSpPr>
+        <p:spPr>
+          <a:xfrm>
+            <a:off x="7242048" y="4608576"/>
+            <a:ext cx="3566160" cy="310896"/>
+          </a:xfrm>
+          <a:prstGeom prst="rect">
+            <a:avLst/>
+          </a:prstGeom>
+          <a:noFill/>
+        </p:spPr>
+        <p:txBody>
+          <a:bodyPr wrap="square" anchor="ctr" lIns="0" rIns="0" tIns="0" bIns="0">
+            <a:spAutoFit/>
+          </a:bodyPr>
+          <a:lstStyle/>
+          <a:p>
+            <a:r>
+              <a:rPr sz="1600" b="0">
+                <a:solidFill>
+                  <a:srgbClr val="5F6B7A"/>
+                </a:solidFill>
+              </a:rPr>
+              <a:t>deterministic validation result</a:t>
+            </a:r>
           </a:p>
         </p:txBody>
       </p:sp>

</xml_diff>

<commit_message>
Balance visual evidence and actor colors
</commit_message>
<xml_diff>
--- a/artifacts/mdpr-vs-skill/mdpr-skill-from-actual-md-run.pptx
+++ b/artifacts/mdpr-vs-skill/mdpr-skill-from-actual-md-run.pptx
@@ -3654,7 +3654,7 @@
                   <a:srgbClr val="5F6B7A"/>
                 </a:solidFill>
               </a:rPr>
-              <a:t>93,102 chars</a:t>
+              <a:t>93,383 chars</a:t>
             </a:r>
           </a:p>
         </p:txBody>
@@ -3954,7 +3954,7 @@
             <a:r>
               <a:rPr sz="1800" b="1">
                 <a:solidFill>
-                  <a:srgbClr val="7C3AED"/>
+                  <a:srgbClr val="0F766E"/>
                 </a:solidFill>
               </a:rPr>
               <a:t>2. MDPR output</a:t>
@@ -4023,7 +4023,7 @@
                   <a:srgbClr val="5F6B7A"/>
                 </a:solidFill>
               </a:rPr>
-              <a:t>449 editable text frames</a:t>
+              <a:t>442 editable text frames</a:t>
             </a:r>
           </a:p>
         </p:txBody>
@@ -4266,7 +4266,7 @@
             <a:r>
               <a:rPr sz="1800" b="1">
                 <a:solidFill>
-                  <a:srgbClr val="BE123C"/>
+                  <a:srgbClr val="7C3AED"/>
                 </a:solidFill>
               </a:rPr>
               <a:t>3. mdpr-skill review</a:t>
@@ -5322,7 +5322,7 @@
                   <a:srgbClr val="5F6B7A"/>
                 </a:solidFill>
               </a:rPr>
-              <a:t>63,182 chars</a:t>
+              <a:t>63,463 chars</a:t>
             </a:r>
           </a:p>
         </p:txBody>
@@ -13292,7 +13292,7 @@
                             <a:srgbClr val="111827"/>
                           </a:solidFill>
                         </a:rPr>
-                        <a:t>64,408</a:t>
+                        <a:t>64,689</a:t>
                       </a:r>
                     </a:p>
                   </a:txBody>
@@ -13600,7 +13600,7 @@
             <a:r>
               <a:rPr sz="2000" b="1">
                 <a:solidFill>
-                  <a:srgbClr val="0F766E"/>
+                  <a:srgbClr val="7C3AED"/>
                 </a:solidFill>
               </a:rPr>
               <a:t>mdpr-skill may suggest</a:t>
@@ -13623,11 +13623,11 @@
             <a:avLst/>
           </a:prstGeom>
           <a:solidFill>
-            <a:srgbClr val="0F766E"/>
+            <a:srgbClr val="7C3AED"/>
           </a:solidFill>
           <a:ln>
             <a:solidFill>
-              <a:srgbClr val="0F766E"/>
+              <a:srgbClr val="7C3AED"/>
             </a:solidFill>
           </a:ln>
         </p:spPr>
@@ -13734,11 +13734,11 @@
             <a:avLst/>
           </a:prstGeom>
           <a:solidFill>
-            <a:srgbClr val="0F766E"/>
+            <a:srgbClr val="7C3AED"/>
           </a:solidFill>
           <a:ln>
             <a:solidFill>
-              <a:srgbClr val="0F766E"/>
+              <a:srgbClr val="7C3AED"/>
             </a:solidFill>
           </a:ln>
         </p:spPr>
@@ -13845,11 +13845,11 @@
             <a:avLst/>
           </a:prstGeom>
           <a:solidFill>
-            <a:srgbClr val="0F766E"/>
+            <a:srgbClr val="7C3AED"/>
           </a:solidFill>
           <a:ln>
             <a:solidFill>
-              <a:srgbClr val="0F766E"/>
+              <a:srgbClr val="7C3AED"/>
             </a:solidFill>
           </a:ln>
         </p:spPr>
@@ -14011,7 +14011,7 @@
             <a:r>
               <a:rPr sz="2000" b="1">
                 <a:solidFill>
-                  <a:srgbClr val="7C3AED"/>
+                  <a:srgbClr val="0F766E"/>
                 </a:solidFill>
               </a:rPr>
               <a:t>MDPR still decides</a:t>
@@ -14044,7 +14044,7 @@
             <a:r>
               <a:rPr sz="1800" b="1">
                 <a:solidFill>
-                  <a:srgbClr val="7C3AED"/>
+                  <a:srgbClr val="0F766E"/>
                 </a:solidFill>
               </a:rPr>
               <a:t>01</a:t>
@@ -14143,7 +14143,7 @@
             <a:r>
               <a:rPr sz="1800" b="1">
                 <a:solidFill>
-                  <a:srgbClr val="7C3AED"/>
+                  <a:srgbClr val="0F766E"/>
                 </a:solidFill>
               </a:rPr>
               <a:t>02</a:t>
@@ -14242,7 +14242,7 @@
             <a:r>
               <a:rPr sz="1800" b="1">
                 <a:solidFill>
-                  <a:srgbClr val="7C3AED"/>
+                  <a:srgbClr val="0F766E"/>
                 </a:solidFill>
               </a:rPr>
               <a:t>03</a:t>

</xml_diff>

<commit_message>
Record additional Pro cycle 3 validator fix
</commit_message>
<xml_diff>
--- a/artifacts/mdpr-vs-skill/mdpr-skill-from-actual-md-run.pptx
+++ b/artifacts/mdpr-vs-skill/mdpr-skill-from-actual-md-run.pptx
@@ -3654,7 +3654,7 @@
                   <a:srgbClr val="5F6B7A"/>
                 </a:solidFill>
               </a:rPr>
-              <a:t>97,905 chars</a:t>
+              <a:t>98,301 chars</a:t>
             </a:r>
           </a:p>
         </p:txBody>
@@ -5322,7 +5322,7 @@
                   <a:srgbClr val="5F6B7A"/>
                 </a:solidFill>
               </a:rPr>
-              <a:t>66,941 chars</a:t>
+              <a:t>67,337 chars</a:t>
             </a:r>
           </a:p>
         </p:txBody>
@@ -13292,7 +13292,7 @@
                             <a:srgbClr val="111827"/>
                           </a:solidFill>
                         </a:rPr>
-                        <a:t>68,167</a:t>
+                        <a:t>68,563</a:t>
                       </a:r>
                     </a:p>
                   </a:txBody>

</xml_diff>

<commit_message>
Refresh hierarchical comparison evidence
</commit_message>
<xml_diff>
--- a/artifacts/mdpr-vs-skill/mdpr-skill-from-actual-md-run.pptx
+++ b/artifacts/mdpr-vs-skill/mdpr-skill-from-actual-md-run.pptx
@@ -3654,7 +3654,7 @@
                   <a:srgbClr val="5F6B7A"/>
                 </a:solidFill>
               </a:rPr>
-              <a:t>98,301 chars</a:t>
+              <a:t>100,214 chars</a:t>
             </a:r>
           </a:p>
         </p:txBody>
@@ -3990,7 +3990,7 @@
                   <a:srgbClr val="5F6B7A"/>
                 </a:solidFill>
               </a:rPr>
-              <a:t>35 slides</a:t>
+              <a:t>32 slides</a:t>
             </a:r>
           </a:p>
         </p:txBody>
@@ -4023,7 +4023,7 @@
                   <a:srgbClr val="5F6B7A"/>
                 </a:solidFill>
               </a:rPr>
-              <a:t>389 editable text frames</a:t>
+              <a:t>344 editable text frames</a:t>
             </a:r>
           </a:p>
         </p:txBody>
@@ -4056,7 +4056,7 @@
                   <a:srgbClr val="5F6B7A"/>
                 </a:solidFill>
               </a:rPr>
-              <a:t>3 tables, 0 charts</a:t>
+              <a:t>5 tables, 0 charts</a:t>
             </a:r>
           </a:p>
         </p:txBody>
@@ -5322,7 +5322,7 @@
                   <a:srgbClr val="5F6B7A"/>
                 </a:solidFill>
               </a:rPr>
-              <a:t>67,337 chars</a:t>
+              <a:t>68,805 chars</a:t>
             </a:r>
           </a:p>
         </p:txBody>
@@ -5808,7 +5808,7 @@
                   <a:srgbClr val="5F6B7A"/>
                 </a:solidFill>
               </a:rPr>
-              <a:t>22,299 chars</a:t>
+              <a:t>22,744 chars</a:t>
             </a:r>
           </a:p>
         </p:txBody>
@@ -13292,7 +13292,7 @@
                             <a:srgbClr val="111827"/>
                           </a:solidFill>
                         </a:rPr>
-                        <a:t>68,563</a:t>
+                        <a:t>70,031</a:t>
                       </a:r>
                     </a:p>
                   </a:txBody>
@@ -13464,7 +13464,7 @@
                             <a:srgbClr val="111827"/>
                           </a:solidFill>
                         </a:rPr>
-                        <a:t>22,299</a:t>
+                        <a:t>22,744</a:t>
                       </a:r>
                     </a:p>
                   </a:txBody>

</xml_diff>

<commit_message>
Document verified PPTX font portability
</commit_message>
<xml_diff>
--- a/artifacts/mdpr-vs-skill/mdpr-skill-from-actual-md-run.pptx
+++ b/artifacts/mdpr-vs-skill/mdpr-skill-from-actual-md-run.pptx
@@ -3654,7 +3654,7 @@
                   <a:srgbClr val="5F6B7A"/>
                 </a:solidFill>
               </a:rPr>
-              <a:t>100,214 chars</a:t>
+              <a:t>102,167 chars</a:t>
             </a:r>
           </a:p>
         </p:txBody>
@@ -5322,7 +5322,7 @@
                   <a:srgbClr val="5F6B7A"/>
                 </a:solidFill>
               </a:rPr>
-              <a:t>68,805 chars</a:t>
+              <a:t>69,918 chars</a:t>
             </a:r>
           </a:p>
         </p:txBody>
@@ -5808,7 +5808,7 @@
                   <a:srgbClr val="5F6B7A"/>
                 </a:solidFill>
               </a:rPr>
-              <a:t>22,744 chars</a:t>
+              <a:t>23,584 chars</a:t>
             </a:r>
           </a:p>
         </p:txBody>
@@ -13292,7 +13292,7 @@
                             <a:srgbClr val="111827"/>
                           </a:solidFill>
                         </a:rPr>
-                        <a:t>70,031</a:t>
+                        <a:t>71,144</a:t>
                       </a:r>
                     </a:p>
                   </a:txBody>
@@ -13464,7 +13464,7 @@
                             <a:srgbClr val="111827"/>
                           </a:solidFill>
                         </a:rPr>
-                        <a:t>22,744</a:t>
+                        <a:t>23,584</a:t>
                       </a:r>
                     </a:p>
                   </a:txBody>

</xml_diff>

<commit_message>
Document hash-bound font license evidence
</commit_message>
<xml_diff>
--- a/artifacts/mdpr-vs-skill/mdpr-skill-from-actual-md-run.pptx
+++ b/artifacts/mdpr-vs-skill/mdpr-skill-from-actual-md-run.pptx
@@ -3654,7 +3654,7 @@
                   <a:srgbClr val="5F6B7A"/>
                 </a:solidFill>
               </a:rPr>
-              <a:t>102,167 chars</a:t>
+              <a:t>104,627 chars</a:t>
             </a:r>
           </a:p>
         </p:txBody>
@@ -5322,7 +5322,7 @@
                   <a:srgbClr val="5F6B7A"/>
                 </a:solidFill>
               </a:rPr>
-              <a:t>69,918 chars</a:t>
+              <a:t>71,930 chars</a:t>
             </a:r>
           </a:p>
         </p:txBody>
@@ -5808,7 +5808,7 @@
                   <a:srgbClr val="5F6B7A"/>
                 </a:solidFill>
               </a:rPr>
-              <a:t>23,584 chars</a:t>
+              <a:t>24,032 chars</a:t>
             </a:r>
           </a:p>
         </p:txBody>
@@ -13292,7 +13292,7 @@
                             <a:srgbClr val="111827"/>
                           </a:solidFill>
                         </a:rPr>
-                        <a:t>71,144</a:t>
+                        <a:t>73,156</a:t>
                       </a:r>
                     </a:p>
                   </a:txBody>
@@ -13464,7 +13464,7 @@
                             <a:srgbClr val="111827"/>
                           </a:solidFill>
                         </a:rPr>
-                        <a:t>23,584</a:t>
+                        <a:t>24,032</a:t>
                       </a:r>
                     </a:p>
                   </a:txBody>

</xml_diff>

<commit_message>
Streamline README entry points
</commit_message>
<xml_diff>
--- a/artifacts/mdpr-vs-skill/mdpr-skill-from-actual-md-run.pptx
+++ b/artifacts/mdpr-vs-skill/mdpr-skill-from-actual-md-run.pptx
@@ -168,7 +168,7 @@
                   <c:v>41</c:v>
                 </c:pt>
                 <c:pt idx="2">
-                  <c:v>14</c:v>
+                  <c:v>15</c:v>
                 </c:pt>
               </c:numCache>
             </c:numRef>
@@ -3621,7 +3621,7 @@
                   <a:srgbClr val="5F6B7A"/>
                 </a:solidFill>
               </a:rPr>
-              <a:t>185 headings</a:t>
+              <a:t>186 headings</a:t>
             </a:r>
           </a:p>
         </p:txBody>
@@ -3654,7 +3654,7 @@
                   <a:srgbClr val="5F6B7A"/>
                 </a:solidFill>
               </a:rPr>
-              <a:t>104,627 chars</a:t>
+              <a:t>104,352 chars</a:t>
             </a:r>
           </a:p>
         </p:txBody>
@@ -5808,7 +5808,7 @@
                   <a:srgbClr val="5F6B7A"/>
                 </a:solidFill>
               </a:rPr>
-              <a:t>24,032 chars</a:t>
+              <a:t>23,757 chars</a:t>
             </a:r>
           </a:p>
         </p:txBody>
@@ -13443,7 +13443,7 @@
                             <a:srgbClr val="111827"/>
                           </a:solidFill>
                         </a:rPr>
-                        <a:t>14</a:t>
+                        <a:t>15</a:t>
                       </a:r>
                     </a:p>
                   </a:txBody>
@@ -13464,7 +13464,7 @@
                             <a:srgbClr val="111827"/>
                           </a:solidFill>
                         </a:rPr>
-                        <a:t>24,032</a:t>
+                        <a:t>23,757</a:t>
                       </a:r>
                     </a:p>
                   </a:txBody>

</xml_diff>

<commit_message>
Break repeated skill evidence card surfaces
</commit_message>
<xml_diff>
--- a/artifacts/mdpr-vs-skill/mdpr-skill-from-actual-md-run.pptx
+++ b/artifacts/mdpr-vs-skill/mdpr-skill-from-actual-md-run.pptx
@@ -11051,24 +11051,24 @@
       </p:sp>
       <p:sp>
         <p:nvSpPr>
-          <p:cNvPr id="4" name="example_0_card"/>
+          <p:cNvPr id="4" name="example_0_icon_doc"/>
           <p:cNvSpPr/>
           <p:nvPr/>
         </p:nvSpPr>
         <p:spPr>
           <a:xfrm>
-            <a:off x="658368" y="1353312"/>
-            <a:ext cx="3154680" cy="1737360"/>
+            <a:off x="822959" y="1517904"/>
+            <a:ext cx="285292" cy="368503"/>
           </a:xfrm>
           <a:prstGeom prst="roundRect">
             <a:avLst/>
           </a:prstGeom>
           <a:solidFill>
-            <a:srgbClr val="FFFDF8"/>
+            <a:srgbClr val="111827"/>
           </a:solidFill>
           <a:ln>
             <a:solidFill>
-              <a:srgbClr val="D7CDBD"/>
+              <a:srgbClr val="111827"/>
             </a:solidFill>
           </a:ln>
         </p:spPr>
@@ -11096,13 +11096,247 @@
       </p:sp>
       <p:sp>
         <p:nvSpPr>
-          <p:cNvPr id="5" name="example_0_icon_doc"/>
+          <p:cNvPr id="5" name="example_0_icon_line_0"/>
           <p:cNvSpPr/>
           <p:nvPr/>
         </p:nvSpPr>
         <p:spPr>
           <a:xfrm>
-            <a:off x="822959" y="1517904"/>
+            <a:off x="894283" y="1613001"/>
+            <a:ext cx="148590" cy="20802"/>
+          </a:xfrm>
+          <a:prstGeom prst="rect">
+            <a:avLst/>
+          </a:prstGeom>
+          <a:solidFill>
+            <a:srgbClr val="F7F2EA"/>
+          </a:solidFill>
+          <a:ln>
+            <a:solidFill>
+              <a:srgbClr val="F7F2EA"/>
+            </a:solidFill>
+          </a:ln>
+        </p:spPr>
+        <p:style>
+          <a:lnRef idx="1">
+            <a:schemeClr val="accent1"/>
+          </a:lnRef>
+          <a:fillRef idx="3">
+            <a:schemeClr val="accent1"/>
+          </a:fillRef>
+          <a:effectRef idx="2">
+            <a:schemeClr val="accent1"/>
+          </a:effectRef>
+          <a:fontRef idx="minor">
+            <a:schemeClr val="lt1"/>
+          </a:fontRef>
+        </p:style>
+        <p:txBody>
+          <a:bodyPr rtlCol="0" anchor="ctr"/>
+          <a:lstStyle/>
+          <a:p>
+            <a:pPr algn="ctr"/>
+          </a:p>
+        </p:txBody>
+      </p:sp>
+      <p:sp>
+        <p:nvSpPr>
+          <p:cNvPr id="6" name="example_0_icon_line_1"/>
+          <p:cNvSpPr/>
+          <p:nvPr/>
+        </p:nvSpPr>
+        <p:spPr>
+          <a:xfrm>
+            <a:off x="894283" y="1690268"/>
+            <a:ext cx="148590" cy="20802"/>
+          </a:xfrm>
+          <a:prstGeom prst="rect">
+            <a:avLst/>
+          </a:prstGeom>
+          <a:solidFill>
+            <a:srgbClr val="F7F2EA"/>
+          </a:solidFill>
+          <a:ln>
+            <a:solidFill>
+              <a:srgbClr val="F7F2EA"/>
+            </a:solidFill>
+          </a:ln>
+        </p:spPr>
+        <p:style>
+          <a:lnRef idx="1">
+            <a:schemeClr val="accent1"/>
+          </a:lnRef>
+          <a:fillRef idx="3">
+            <a:schemeClr val="accent1"/>
+          </a:fillRef>
+          <a:effectRef idx="2">
+            <a:schemeClr val="accent1"/>
+          </a:effectRef>
+          <a:fontRef idx="minor">
+            <a:schemeClr val="lt1"/>
+          </a:fontRef>
+        </p:style>
+        <p:txBody>
+          <a:bodyPr rtlCol="0" anchor="ctr"/>
+          <a:lstStyle/>
+          <a:p>
+            <a:pPr algn="ctr"/>
+          </a:p>
+        </p:txBody>
+      </p:sp>
+      <p:sp>
+        <p:nvSpPr>
+          <p:cNvPr id="7" name="example_0_icon_line_2"/>
+          <p:cNvSpPr/>
+          <p:nvPr/>
+        </p:nvSpPr>
+        <p:spPr>
+          <a:xfrm>
+            <a:off x="894283" y="1767535"/>
+            <a:ext cx="148590" cy="20802"/>
+          </a:xfrm>
+          <a:prstGeom prst="rect">
+            <a:avLst/>
+          </a:prstGeom>
+          <a:solidFill>
+            <a:srgbClr val="F7F2EA"/>
+          </a:solidFill>
+          <a:ln>
+            <a:solidFill>
+              <a:srgbClr val="F7F2EA"/>
+            </a:solidFill>
+          </a:ln>
+        </p:spPr>
+        <p:style>
+          <a:lnRef idx="1">
+            <a:schemeClr val="accent1"/>
+          </a:lnRef>
+          <a:fillRef idx="3">
+            <a:schemeClr val="accent1"/>
+          </a:fillRef>
+          <a:effectRef idx="2">
+            <a:schemeClr val="accent1"/>
+          </a:effectRef>
+          <a:fontRef idx="minor">
+            <a:schemeClr val="lt1"/>
+          </a:fontRef>
+        </p:style>
+        <p:txBody>
+          <a:bodyPr rtlCol="0" anchor="ctr"/>
+          <a:lstStyle/>
+          <a:p>
+            <a:pPr algn="ctr"/>
+          </a:p>
+        </p:txBody>
+      </p:sp>
+      <p:sp>
+        <p:nvSpPr>
+          <p:cNvPr id="8" name="example_0_title"/>
+          <p:cNvSpPr txBox="1"/>
+          <p:nvPr/>
+        </p:nvSpPr>
+        <p:spPr>
+          <a:xfrm>
+            <a:off x="1463040" y="1536192"/>
+            <a:ext cx="2167128" cy="347472"/>
+          </a:xfrm>
+          <a:prstGeom prst="rect">
+            <a:avLst/>
+          </a:prstGeom>
+          <a:noFill/>
+        </p:spPr>
+        <p:txBody>
+          <a:bodyPr wrap="square" anchor="ctr" lIns="0" rIns="0" tIns="0" bIns="0">
+            <a:spAutoFit/>
+          </a:bodyPr>
+          <a:lstStyle/>
+          <a:p>
+            <a:r>
+              <a:rPr sz="1800" b="1">
+                <a:solidFill>
+                  <a:srgbClr val="0F766E"/>
+                </a:solidFill>
+              </a:rPr>
+              <a:t>Basic</a:t>
+            </a:r>
+          </a:p>
+        </p:txBody>
+      </p:sp>
+      <p:sp>
+        <p:nvSpPr>
+          <p:cNvPr id="9" name="example_0_body_0"/>
+          <p:cNvSpPr txBox="1"/>
+          <p:nvPr/>
+        </p:nvSpPr>
+        <p:spPr>
+          <a:xfrm>
+            <a:off x="1463040" y="1993391"/>
+            <a:ext cx="2167128" cy="310896"/>
+          </a:xfrm>
+          <a:prstGeom prst="rect">
+            <a:avLst/>
+          </a:prstGeom>
+          <a:noFill/>
+        </p:spPr>
+        <p:txBody>
+          <a:bodyPr wrap="square" anchor="ctr" lIns="0" rIns="0" tIns="0" bIns="0">
+            <a:spAutoFit/>
+          </a:bodyPr>
+          <a:lstStyle/>
+          <a:p>
+            <a:r>
+              <a:rPr sz="1600" b="0">
+                <a:solidFill>
+                  <a:srgbClr val="5F6B7A"/>
+                </a:solidFill>
+              </a:rPr>
+              <a:t>AI Workflow Automation Proposal</a:t>
+            </a:r>
+          </a:p>
+        </p:txBody>
+      </p:sp>
+      <p:sp>
+        <p:nvSpPr>
+          <p:cNvPr id="10" name="example_0_body_1"/>
+          <p:cNvSpPr txBox="1"/>
+          <p:nvPr/>
+        </p:nvSpPr>
+        <p:spPr>
+          <a:xfrm>
+            <a:off x="1463040" y="2377439"/>
+            <a:ext cx="2167128" cy="310896"/>
+          </a:xfrm>
+          <a:prstGeom prst="rect">
+            <a:avLst/>
+          </a:prstGeom>
+          <a:noFill/>
+        </p:spPr>
+        <p:txBody>
+          <a:bodyPr wrap="square" anchor="ctr" lIns="0" rIns="0" tIns="0" bIns="0">
+            <a:spAutoFit/>
+          </a:bodyPr>
+          <a:lstStyle/>
+          <a:p>
+            <a:r>
+              <a:rPr sz="1600" b="0">
+                <a:solidFill>
+                  <a:srgbClr val="5F6B7A"/>
+                </a:solidFill>
+              </a:rPr>
+              <a:t>10 headings · 1,255 chars</a:t>
+            </a:r>
+          </a:p>
+        </p:txBody>
+      </p:sp>
+      <p:sp>
+        <p:nvSpPr>
+          <p:cNvPr id="11" name="example_1_icon_doc"/>
+          <p:cNvSpPr/>
+          <p:nvPr/>
+        </p:nvSpPr>
+        <p:spPr>
+          <a:xfrm>
+            <a:off x="4480559" y="1517904"/>
             <a:ext cx="285292" cy="368503"/>
           </a:xfrm>
           <a:prstGeom prst="roundRect">
@@ -11141,13 +11375,13 @@
       </p:sp>
       <p:sp>
         <p:nvSpPr>
-          <p:cNvPr id="6" name="example_0_icon_line_0"/>
+          <p:cNvPr id="12" name="example_1_icon_line_0"/>
           <p:cNvSpPr/>
           <p:nvPr/>
         </p:nvSpPr>
         <p:spPr>
           <a:xfrm>
-            <a:off x="894283" y="1613001"/>
+            <a:off x="4551883" y="1613001"/>
             <a:ext cx="148590" cy="20802"/>
           </a:xfrm>
           <a:prstGeom prst="rect">
@@ -11186,13 +11420,13 @@
       </p:sp>
       <p:sp>
         <p:nvSpPr>
-          <p:cNvPr id="7" name="example_0_icon_line_1"/>
+          <p:cNvPr id="13" name="example_1_icon_line_1"/>
           <p:cNvSpPr/>
           <p:nvPr/>
         </p:nvSpPr>
         <p:spPr>
           <a:xfrm>
-            <a:off x="894283" y="1690268"/>
+            <a:off x="4551883" y="1690268"/>
             <a:ext cx="148590" cy="20802"/>
           </a:xfrm>
           <a:prstGeom prst="rect">
@@ -11231,13 +11465,13 @@
       </p:sp>
       <p:sp>
         <p:nvSpPr>
-          <p:cNvPr id="8" name="example_0_icon_line_2"/>
+          <p:cNvPr id="14" name="example_1_icon_line_2"/>
           <p:cNvSpPr/>
           <p:nvPr/>
         </p:nvSpPr>
         <p:spPr>
           <a:xfrm>
-            <a:off x="894283" y="1767535"/>
+            <a:off x="4551883" y="1767535"/>
             <a:ext cx="148590" cy="20802"/>
           </a:xfrm>
           <a:prstGeom prst="rect">
@@ -11276,13 +11510,13 @@
       </p:sp>
       <p:sp>
         <p:nvSpPr>
-          <p:cNvPr id="9" name="example_0_title"/>
+          <p:cNvPr id="15" name="example_1_title"/>
           <p:cNvSpPr txBox="1"/>
           <p:nvPr/>
         </p:nvSpPr>
         <p:spPr>
           <a:xfrm>
-            <a:off x="1463040" y="1536192"/>
+            <a:off x="5120640" y="1536192"/>
             <a:ext cx="2167128" cy="347472"/>
           </a:xfrm>
           <a:prstGeom prst="rect">
@@ -11299,23 +11533,23 @@
             <a:r>
               <a:rPr sz="1800" b="1">
                 <a:solidFill>
-                  <a:srgbClr val="0F766E"/>
+                  <a:srgbClr val="7C3AED"/>
                 </a:solidFill>
               </a:rPr>
-              <a:t>Basic</a:t>
-            </a:r>
-          </a:p>
-        </p:txBody>
-      </p:sp>
-      <p:sp>
-        <p:nvSpPr>
-          <p:cNvPr id="10" name="example_0_body_0"/>
+              <a:t>Comparison</a:t>
+            </a:r>
+          </a:p>
+        </p:txBody>
+      </p:sp>
+      <p:sp>
+        <p:nvSpPr>
+          <p:cNvPr id="16" name="example_1_body_0"/>
           <p:cNvSpPr txBox="1"/>
           <p:nvPr/>
         </p:nvSpPr>
         <p:spPr>
           <a:xfrm>
-            <a:off x="1463040" y="1993391"/>
+            <a:off x="5120640" y="1993391"/>
             <a:ext cx="2167128" cy="310896"/>
           </a:xfrm>
           <a:prstGeom prst="rect">
@@ -11335,20 +11569,20 @@
                   <a:srgbClr val="5F6B7A"/>
                 </a:solidFill>
               </a:rPr>
-              <a:t>AI Workflow Automation Proposal</a:t>
-            </a:r>
-          </a:p>
-        </p:txBody>
-      </p:sp>
-      <p:sp>
-        <p:nvSpPr>
-          <p:cNvPr id="11" name="example_0_body_1"/>
+              <a:t>Comparison Structure Example</a:t>
+            </a:r>
+          </a:p>
+        </p:txBody>
+      </p:sp>
+      <p:sp>
+        <p:nvSpPr>
+          <p:cNvPr id="17" name="example_1_body_1"/>
           <p:cNvSpPr txBox="1"/>
           <p:nvPr/>
         </p:nvSpPr>
         <p:spPr>
           <a:xfrm>
-            <a:off x="1463040" y="2377439"/>
+            <a:off x="5120640" y="2377439"/>
             <a:ext cx="2167128" cy="310896"/>
           </a:xfrm>
           <a:prstGeom prst="rect">
@@ -11368,31 +11602,31 @@
                   <a:srgbClr val="5F6B7A"/>
                 </a:solidFill>
               </a:rPr>
-              <a:t>10 headings · 1,255 chars</a:t>
-            </a:r>
-          </a:p>
-        </p:txBody>
-      </p:sp>
-      <p:sp>
-        <p:nvSpPr>
-          <p:cNvPr id="12" name="example_1_card"/>
+              <a:t>4 headings · 307 chars</a:t>
+            </a:r>
+          </a:p>
+        </p:txBody>
+      </p:sp>
+      <p:sp>
+        <p:nvSpPr>
+          <p:cNvPr id="18" name="example_2_icon_doc"/>
           <p:cNvSpPr/>
           <p:nvPr/>
         </p:nvSpPr>
         <p:spPr>
           <a:xfrm>
-            <a:off x="4315968" y="1353312"/>
-            <a:ext cx="3154680" cy="1737360"/>
+            <a:off x="8138160" y="1517904"/>
+            <a:ext cx="285292" cy="368503"/>
           </a:xfrm>
           <a:prstGeom prst="roundRect">
             <a:avLst/>
           </a:prstGeom>
           <a:solidFill>
-            <a:srgbClr val="FFFDF8"/>
+            <a:srgbClr val="111827"/>
           </a:solidFill>
           <a:ln>
             <a:solidFill>
-              <a:srgbClr val="D7CDBD"/>
+              <a:srgbClr val="111827"/>
             </a:solidFill>
           </a:ln>
         </p:spPr>
@@ -11420,13 +11654,247 @@
       </p:sp>
       <p:sp>
         <p:nvSpPr>
-          <p:cNvPr id="13" name="example_1_icon_doc"/>
+          <p:cNvPr id="19" name="example_2_icon_line_0"/>
           <p:cNvSpPr/>
           <p:nvPr/>
         </p:nvSpPr>
         <p:spPr>
           <a:xfrm>
-            <a:off x="4480559" y="1517904"/>
+            <a:off x="8209483" y="1613001"/>
+            <a:ext cx="148590" cy="20802"/>
+          </a:xfrm>
+          <a:prstGeom prst="rect">
+            <a:avLst/>
+          </a:prstGeom>
+          <a:solidFill>
+            <a:srgbClr val="F7F2EA"/>
+          </a:solidFill>
+          <a:ln>
+            <a:solidFill>
+              <a:srgbClr val="F7F2EA"/>
+            </a:solidFill>
+          </a:ln>
+        </p:spPr>
+        <p:style>
+          <a:lnRef idx="1">
+            <a:schemeClr val="accent1"/>
+          </a:lnRef>
+          <a:fillRef idx="3">
+            <a:schemeClr val="accent1"/>
+          </a:fillRef>
+          <a:effectRef idx="2">
+            <a:schemeClr val="accent1"/>
+          </a:effectRef>
+          <a:fontRef idx="minor">
+            <a:schemeClr val="lt1"/>
+          </a:fontRef>
+        </p:style>
+        <p:txBody>
+          <a:bodyPr rtlCol="0" anchor="ctr"/>
+          <a:lstStyle/>
+          <a:p>
+            <a:pPr algn="ctr"/>
+          </a:p>
+        </p:txBody>
+      </p:sp>
+      <p:sp>
+        <p:nvSpPr>
+          <p:cNvPr id="20" name="example_2_icon_line_1"/>
+          <p:cNvSpPr/>
+          <p:nvPr/>
+        </p:nvSpPr>
+        <p:spPr>
+          <a:xfrm>
+            <a:off x="8209483" y="1690268"/>
+            <a:ext cx="148590" cy="20802"/>
+          </a:xfrm>
+          <a:prstGeom prst="rect">
+            <a:avLst/>
+          </a:prstGeom>
+          <a:solidFill>
+            <a:srgbClr val="F7F2EA"/>
+          </a:solidFill>
+          <a:ln>
+            <a:solidFill>
+              <a:srgbClr val="F7F2EA"/>
+            </a:solidFill>
+          </a:ln>
+        </p:spPr>
+        <p:style>
+          <a:lnRef idx="1">
+            <a:schemeClr val="accent1"/>
+          </a:lnRef>
+          <a:fillRef idx="3">
+            <a:schemeClr val="accent1"/>
+          </a:fillRef>
+          <a:effectRef idx="2">
+            <a:schemeClr val="accent1"/>
+          </a:effectRef>
+          <a:fontRef idx="minor">
+            <a:schemeClr val="lt1"/>
+          </a:fontRef>
+        </p:style>
+        <p:txBody>
+          <a:bodyPr rtlCol="0" anchor="ctr"/>
+          <a:lstStyle/>
+          <a:p>
+            <a:pPr algn="ctr"/>
+          </a:p>
+        </p:txBody>
+      </p:sp>
+      <p:sp>
+        <p:nvSpPr>
+          <p:cNvPr id="21" name="example_2_icon_line_2"/>
+          <p:cNvSpPr/>
+          <p:nvPr/>
+        </p:nvSpPr>
+        <p:spPr>
+          <a:xfrm>
+            <a:off x="8209483" y="1767535"/>
+            <a:ext cx="148590" cy="20802"/>
+          </a:xfrm>
+          <a:prstGeom prst="rect">
+            <a:avLst/>
+          </a:prstGeom>
+          <a:solidFill>
+            <a:srgbClr val="F7F2EA"/>
+          </a:solidFill>
+          <a:ln>
+            <a:solidFill>
+              <a:srgbClr val="F7F2EA"/>
+            </a:solidFill>
+          </a:ln>
+        </p:spPr>
+        <p:style>
+          <a:lnRef idx="1">
+            <a:schemeClr val="accent1"/>
+          </a:lnRef>
+          <a:fillRef idx="3">
+            <a:schemeClr val="accent1"/>
+          </a:fillRef>
+          <a:effectRef idx="2">
+            <a:schemeClr val="accent1"/>
+          </a:effectRef>
+          <a:fontRef idx="minor">
+            <a:schemeClr val="lt1"/>
+          </a:fontRef>
+        </p:style>
+        <p:txBody>
+          <a:bodyPr rtlCol="0" anchor="ctr"/>
+          <a:lstStyle/>
+          <a:p>
+            <a:pPr algn="ctr"/>
+          </a:p>
+        </p:txBody>
+      </p:sp>
+      <p:sp>
+        <p:nvSpPr>
+          <p:cNvPr id="22" name="example_2_title"/>
+          <p:cNvSpPr txBox="1"/>
+          <p:nvPr/>
+        </p:nvSpPr>
+        <p:spPr>
+          <a:xfrm>
+            <a:off x="8778240" y="1536192"/>
+            <a:ext cx="2167128" cy="347472"/>
+          </a:xfrm>
+          <a:prstGeom prst="rect">
+            <a:avLst/>
+          </a:prstGeom>
+          <a:noFill/>
+        </p:spPr>
+        <p:txBody>
+          <a:bodyPr wrap="square" anchor="ctr" lIns="0" rIns="0" tIns="0" bIns="0">
+            <a:spAutoFit/>
+          </a:bodyPr>
+          <a:lstStyle/>
+          <a:p>
+            <a:r>
+              <a:rPr sz="1800" b="1">
+                <a:solidFill>
+                  <a:srgbClr val="0F766E"/>
+                </a:solidFill>
+              </a:rPr>
+              <a:t>Pipeline</a:t>
+            </a:r>
+          </a:p>
+        </p:txBody>
+      </p:sp>
+      <p:sp>
+        <p:nvSpPr>
+          <p:cNvPr id="23" name="example_2_body_0"/>
+          <p:cNvSpPr txBox="1"/>
+          <p:nvPr/>
+        </p:nvSpPr>
+        <p:spPr>
+          <a:xfrm>
+            <a:off x="8778240" y="1993391"/>
+            <a:ext cx="2167128" cy="310896"/>
+          </a:xfrm>
+          <a:prstGeom prst="rect">
+            <a:avLst/>
+          </a:prstGeom>
+          <a:noFill/>
+        </p:spPr>
+        <p:txBody>
+          <a:bodyPr wrap="square" anchor="ctr" lIns="0" rIns="0" tIns="0" bIns="0">
+            <a:spAutoFit/>
+          </a:bodyPr>
+          <a:lstStyle/>
+          <a:p>
+            <a:r>
+              <a:rPr sz="1600" b="0">
+                <a:solidFill>
+                  <a:srgbClr val="5F6B7A"/>
+                </a:solidFill>
+              </a:rPr>
+              <a:t>Pipeline Example</a:t>
+            </a:r>
+          </a:p>
+        </p:txBody>
+      </p:sp>
+      <p:sp>
+        <p:nvSpPr>
+          <p:cNvPr id="24" name="example_2_body_1"/>
+          <p:cNvSpPr txBox="1"/>
+          <p:nvPr/>
+        </p:nvSpPr>
+        <p:spPr>
+          <a:xfrm>
+            <a:off x="8778240" y="2377439"/>
+            <a:ext cx="2167128" cy="310896"/>
+          </a:xfrm>
+          <a:prstGeom prst="rect">
+            <a:avLst/>
+          </a:prstGeom>
+          <a:noFill/>
+        </p:spPr>
+        <p:txBody>
+          <a:bodyPr wrap="square" anchor="ctr" lIns="0" rIns="0" tIns="0" bIns="0">
+            <a:spAutoFit/>
+          </a:bodyPr>
+          <a:lstStyle/>
+          <a:p>
+            <a:r>
+              <a:rPr sz="1600" b="0">
+                <a:solidFill>
+                  <a:srgbClr val="5F6B7A"/>
+                </a:solidFill>
+              </a:rPr>
+              <a:t>3 headings · 186 chars</a:t>
+            </a:r>
+          </a:p>
+        </p:txBody>
+      </p:sp>
+      <p:sp>
+        <p:nvSpPr>
+          <p:cNvPr id="25" name="example_3_icon_doc"/>
+          <p:cNvSpPr/>
+          <p:nvPr/>
+        </p:nvSpPr>
+        <p:spPr>
+          <a:xfrm>
+            <a:off x="822959" y="3575304"/>
             <a:ext cx="285292" cy="368503"/>
           </a:xfrm>
           <a:prstGeom prst="roundRect">
@@ -11465,13 +11933,13 @@
       </p:sp>
       <p:sp>
         <p:nvSpPr>
-          <p:cNvPr id="14" name="example_1_icon_line_0"/>
+          <p:cNvPr id="26" name="example_3_icon_line_0"/>
           <p:cNvSpPr/>
           <p:nvPr/>
         </p:nvSpPr>
         <p:spPr>
           <a:xfrm>
-            <a:off x="4551883" y="1613001"/>
+            <a:off x="894283" y="3670401"/>
             <a:ext cx="148590" cy="20802"/>
           </a:xfrm>
           <a:prstGeom prst="rect">
@@ -11510,13 +11978,13 @@
       </p:sp>
       <p:sp>
         <p:nvSpPr>
-          <p:cNvPr id="15" name="example_1_icon_line_1"/>
+          <p:cNvPr id="27" name="example_3_icon_line_1"/>
           <p:cNvSpPr/>
           <p:nvPr/>
         </p:nvSpPr>
         <p:spPr>
           <a:xfrm>
-            <a:off x="4551883" y="1690268"/>
+            <a:off x="894283" y="3747668"/>
             <a:ext cx="148590" cy="20802"/>
           </a:xfrm>
           <a:prstGeom prst="rect">
@@ -11555,13 +12023,13 @@
       </p:sp>
       <p:sp>
         <p:nvSpPr>
-          <p:cNvPr id="16" name="example_1_icon_line_2"/>
+          <p:cNvPr id="28" name="example_3_icon_line_2"/>
           <p:cNvSpPr/>
           <p:nvPr/>
         </p:nvSpPr>
         <p:spPr>
           <a:xfrm>
-            <a:off x="4551883" y="1767535"/>
+            <a:off x="894283" y="3824935"/>
             <a:ext cx="148590" cy="20802"/>
           </a:xfrm>
           <a:prstGeom prst="rect">
@@ -11600,13 +12068,13 @@
       </p:sp>
       <p:sp>
         <p:nvSpPr>
-          <p:cNvPr id="17" name="example_1_title"/>
+          <p:cNvPr id="29" name="example_3_title"/>
           <p:cNvSpPr txBox="1"/>
           <p:nvPr/>
         </p:nvSpPr>
         <p:spPr>
           <a:xfrm>
-            <a:off x="5120640" y="1536192"/>
+            <a:off x="1463040" y="3593592"/>
             <a:ext cx="2167128" cy="347472"/>
           </a:xfrm>
           <a:prstGeom prst="rect">
@@ -11626,20 +12094,20 @@
                   <a:srgbClr val="7C3AED"/>
                 </a:solidFill>
               </a:rPr>
-              <a:t>Comparison</a:t>
-            </a:r>
-          </a:p>
-        </p:txBody>
-      </p:sp>
-      <p:sp>
-        <p:nvSpPr>
-          <p:cNvPr id="18" name="example_1_body_0"/>
+              <a:t>Diagram</a:t>
+            </a:r>
+          </a:p>
+        </p:txBody>
+      </p:sp>
+      <p:sp>
+        <p:nvSpPr>
+          <p:cNvPr id="30" name="example_3_body_0"/>
           <p:cNvSpPr txBox="1"/>
           <p:nvPr/>
         </p:nvSpPr>
         <p:spPr>
           <a:xfrm>
-            <a:off x="5120640" y="1993391"/>
+            <a:off x="1463040" y="4050791"/>
             <a:ext cx="2167128" cy="310896"/>
           </a:xfrm>
           <a:prstGeom prst="rect">
@@ -11659,20 +12127,20 @@
                   <a:srgbClr val="5F6B7A"/>
                 </a:solidFill>
               </a:rPr>
-              <a:t>Comparison Structure Example</a:t>
-            </a:r>
-          </a:p>
-        </p:txBody>
-      </p:sp>
-      <p:sp>
-        <p:nvSpPr>
-          <p:cNvPr id="19" name="example_1_body_1"/>
+              <a:t>Diagram Arrangement Examples</a:t>
+            </a:r>
+          </a:p>
+        </p:txBody>
+      </p:sp>
+      <p:sp>
+        <p:nvSpPr>
+          <p:cNvPr id="31" name="example_3_body_1"/>
           <p:cNvSpPr txBox="1"/>
           <p:nvPr/>
         </p:nvSpPr>
         <p:spPr>
           <a:xfrm>
-            <a:off x="5120640" y="2377439"/>
+            <a:off x="1463040" y="4434840"/>
             <a:ext cx="2167128" cy="310896"/>
           </a:xfrm>
           <a:prstGeom prst="rect">
@@ -11692,31 +12160,31 @@
                   <a:srgbClr val="5F6B7A"/>
                 </a:solidFill>
               </a:rPr>
-              <a:t>4 headings · 307 chars</a:t>
-            </a:r>
-          </a:p>
-        </p:txBody>
-      </p:sp>
-      <p:sp>
-        <p:nvSpPr>
-          <p:cNvPr id="20" name="example_2_card"/>
+              <a:t>6 headings · 457 chars</a:t>
+            </a:r>
+          </a:p>
+        </p:txBody>
+      </p:sp>
+      <p:sp>
+        <p:nvSpPr>
+          <p:cNvPr id="32" name="example_4_icon_doc"/>
           <p:cNvSpPr/>
           <p:nvPr/>
         </p:nvSpPr>
         <p:spPr>
           <a:xfrm>
-            <a:off x="7973568" y="1353312"/>
-            <a:ext cx="3154680" cy="1737360"/>
+            <a:off x="4480559" y="3575304"/>
+            <a:ext cx="285292" cy="368503"/>
           </a:xfrm>
           <a:prstGeom prst="roundRect">
             <a:avLst/>
           </a:prstGeom>
           <a:solidFill>
-            <a:srgbClr val="FFFDF8"/>
+            <a:srgbClr val="111827"/>
           </a:solidFill>
           <a:ln>
             <a:solidFill>
-              <a:srgbClr val="D7CDBD"/>
+              <a:srgbClr val="111827"/>
             </a:solidFill>
           </a:ln>
         </p:spPr>
@@ -11744,13 +12212,247 @@
       </p:sp>
       <p:sp>
         <p:nvSpPr>
-          <p:cNvPr id="21" name="example_2_icon_doc"/>
+          <p:cNvPr id="33" name="example_4_icon_line_0"/>
           <p:cNvSpPr/>
           <p:nvPr/>
         </p:nvSpPr>
         <p:spPr>
           <a:xfrm>
-            <a:off x="8138160" y="1517904"/>
+            <a:off x="4551883" y="3670401"/>
+            <a:ext cx="148590" cy="20802"/>
+          </a:xfrm>
+          <a:prstGeom prst="rect">
+            <a:avLst/>
+          </a:prstGeom>
+          <a:solidFill>
+            <a:srgbClr val="F7F2EA"/>
+          </a:solidFill>
+          <a:ln>
+            <a:solidFill>
+              <a:srgbClr val="F7F2EA"/>
+            </a:solidFill>
+          </a:ln>
+        </p:spPr>
+        <p:style>
+          <a:lnRef idx="1">
+            <a:schemeClr val="accent1"/>
+          </a:lnRef>
+          <a:fillRef idx="3">
+            <a:schemeClr val="accent1"/>
+          </a:fillRef>
+          <a:effectRef idx="2">
+            <a:schemeClr val="accent1"/>
+          </a:effectRef>
+          <a:fontRef idx="minor">
+            <a:schemeClr val="lt1"/>
+          </a:fontRef>
+        </p:style>
+        <p:txBody>
+          <a:bodyPr rtlCol="0" anchor="ctr"/>
+          <a:lstStyle/>
+          <a:p>
+            <a:pPr algn="ctr"/>
+          </a:p>
+        </p:txBody>
+      </p:sp>
+      <p:sp>
+        <p:nvSpPr>
+          <p:cNvPr id="34" name="example_4_icon_line_1"/>
+          <p:cNvSpPr/>
+          <p:nvPr/>
+        </p:nvSpPr>
+        <p:spPr>
+          <a:xfrm>
+            <a:off x="4551883" y="3747668"/>
+            <a:ext cx="148590" cy="20802"/>
+          </a:xfrm>
+          <a:prstGeom prst="rect">
+            <a:avLst/>
+          </a:prstGeom>
+          <a:solidFill>
+            <a:srgbClr val="F7F2EA"/>
+          </a:solidFill>
+          <a:ln>
+            <a:solidFill>
+              <a:srgbClr val="F7F2EA"/>
+            </a:solidFill>
+          </a:ln>
+        </p:spPr>
+        <p:style>
+          <a:lnRef idx="1">
+            <a:schemeClr val="accent1"/>
+          </a:lnRef>
+          <a:fillRef idx="3">
+            <a:schemeClr val="accent1"/>
+          </a:fillRef>
+          <a:effectRef idx="2">
+            <a:schemeClr val="accent1"/>
+          </a:effectRef>
+          <a:fontRef idx="minor">
+            <a:schemeClr val="lt1"/>
+          </a:fontRef>
+        </p:style>
+        <p:txBody>
+          <a:bodyPr rtlCol="0" anchor="ctr"/>
+          <a:lstStyle/>
+          <a:p>
+            <a:pPr algn="ctr"/>
+          </a:p>
+        </p:txBody>
+      </p:sp>
+      <p:sp>
+        <p:nvSpPr>
+          <p:cNvPr id="35" name="example_4_icon_line_2"/>
+          <p:cNvSpPr/>
+          <p:nvPr/>
+        </p:nvSpPr>
+        <p:spPr>
+          <a:xfrm>
+            <a:off x="4551883" y="3824935"/>
+            <a:ext cx="148590" cy="20802"/>
+          </a:xfrm>
+          <a:prstGeom prst="rect">
+            <a:avLst/>
+          </a:prstGeom>
+          <a:solidFill>
+            <a:srgbClr val="F7F2EA"/>
+          </a:solidFill>
+          <a:ln>
+            <a:solidFill>
+              <a:srgbClr val="F7F2EA"/>
+            </a:solidFill>
+          </a:ln>
+        </p:spPr>
+        <p:style>
+          <a:lnRef idx="1">
+            <a:schemeClr val="accent1"/>
+          </a:lnRef>
+          <a:fillRef idx="3">
+            <a:schemeClr val="accent1"/>
+          </a:fillRef>
+          <a:effectRef idx="2">
+            <a:schemeClr val="accent1"/>
+          </a:effectRef>
+          <a:fontRef idx="minor">
+            <a:schemeClr val="lt1"/>
+          </a:fontRef>
+        </p:style>
+        <p:txBody>
+          <a:bodyPr rtlCol="0" anchor="ctr"/>
+          <a:lstStyle/>
+          <a:p>
+            <a:pPr algn="ctr"/>
+          </a:p>
+        </p:txBody>
+      </p:sp>
+      <p:sp>
+        <p:nvSpPr>
+          <p:cNvPr id="36" name="example_4_title"/>
+          <p:cNvSpPr txBox="1"/>
+          <p:nvPr/>
+        </p:nvSpPr>
+        <p:spPr>
+          <a:xfrm>
+            <a:off x="5120640" y="3593592"/>
+            <a:ext cx="2167128" cy="347472"/>
+          </a:xfrm>
+          <a:prstGeom prst="rect">
+            <a:avLst/>
+          </a:prstGeom>
+          <a:noFill/>
+        </p:spPr>
+        <p:txBody>
+          <a:bodyPr wrap="square" anchor="ctr" lIns="0" rIns="0" tIns="0" bIns="0">
+            <a:spAutoFit/>
+          </a:bodyPr>
+          <a:lstStyle/>
+          <a:p>
+            <a:r>
+              <a:rPr sz="1800" b="1">
+                <a:solidFill>
+                  <a:srgbClr val="0F766E"/>
+                </a:solidFill>
+              </a:rPr>
+              <a:t>Five Methods</a:t>
+            </a:r>
+          </a:p>
+        </p:txBody>
+      </p:sp>
+      <p:sp>
+        <p:nvSpPr>
+          <p:cNvPr id="37" name="example_4_body_0"/>
+          <p:cNvSpPr txBox="1"/>
+          <p:nvPr/>
+        </p:nvSpPr>
+        <p:spPr>
+          <a:xfrm>
+            <a:off x="5120640" y="4050791"/>
+            <a:ext cx="2167128" cy="310896"/>
+          </a:xfrm>
+          <a:prstGeom prst="rect">
+            <a:avLst/>
+          </a:prstGeom>
+          <a:noFill/>
+        </p:spPr>
+        <p:txBody>
+          <a:bodyPr wrap="square" anchor="ctr" lIns="0" rIns="0" tIns="0" bIns="0">
+            <a:spAutoFit/>
+          </a:bodyPr>
+          <a:lstStyle/>
+          <a:p>
+            <a:r>
+              <a:rPr sz="1600" b="0">
+                <a:solidFill>
+                  <a:srgbClr val="5F6B7A"/>
+                </a:solidFill>
+              </a:rPr>
+              <a:t>Five-Item Layout Example</a:t>
+            </a:r>
+          </a:p>
+        </p:txBody>
+      </p:sp>
+      <p:sp>
+        <p:nvSpPr>
+          <p:cNvPr id="38" name="example_4_body_1"/>
+          <p:cNvSpPr txBox="1"/>
+          <p:nvPr/>
+        </p:nvSpPr>
+        <p:spPr>
+          <a:xfrm>
+            <a:off x="5120640" y="4434840"/>
+            <a:ext cx="2167128" cy="310896"/>
+          </a:xfrm>
+          <a:prstGeom prst="rect">
+            <a:avLst/>
+          </a:prstGeom>
+          <a:noFill/>
+        </p:spPr>
+        <p:txBody>
+          <a:bodyPr wrap="square" anchor="ctr" lIns="0" rIns="0" tIns="0" bIns="0">
+            <a:spAutoFit/>
+          </a:bodyPr>
+          <a:lstStyle/>
+          <a:p>
+            <a:r>
+              <a:rPr sz="1600" b="0">
+                <a:solidFill>
+                  <a:srgbClr val="5F6B7A"/>
+                </a:solidFill>
+              </a:rPr>
+              <a:t>2 headings · 200 chars</a:t>
+            </a:r>
+          </a:p>
+        </p:txBody>
+      </p:sp>
+      <p:sp>
+        <p:nvSpPr>
+          <p:cNvPr id="39" name="example_5_icon_doc"/>
+          <p:cNvSpPr/>
+          <p:nvPr/>
+        </p:nvSpPr>
+        <p:spPr>
+          <a:xfrm>
+            <a:off x="8138160" y="3575304"/>
             <a:ext cx="285292" cy="368503"/>
           </a:xfrm>
           <a:prstGeom prst="roundRect">
@@ -11789,13 +12491,13 @@
       </p:sp>
       <p:sp>
         <p:nvSpPr>
-          <p:cNvPr id="22" name="example_2_icon_line_0"/>
+          <p:cNvPr id="40" name="example_5_icon_line_0"/>
           <p:cNvSpPr/>
           <p:nvPr/>
         </p:nvSpPr>
         <p:spPr>
           <a:xfrm>
-            <a:off x="8209483" y="1613001"/>
+            <a:off x="8209483" y="3670401"/>
             <a:ext cx="148590" cy="20802"/>
           </a:xfrm>
           <a:prstGeom prst="rect">
@@ -11834,13 +12536,13 @@
       </p:sp>
       <p:sp>
         <p:nvSpPr>
-          <p:cNvPr id="23" name="example_2_icon_line_1"/>
+          <p:cNvPr id="41" name="example_5_icon_line_1"/>
           <p:cNvSpPr/>
           <p:nvPr/>
         </p:nvSpPr>
         <p:spPr>
           <a:xfrm>
-            <a:off x="8209483" y="1690268"/>
+            <a:off x="8209483" y="3747668"/>
             <a:ext cx="148590" cy="20802"/>
           </a:xfrm>
           <a:prstGeom prst="rect">
@@ -11879,13 +12581,13 @@
       </p:sp>
       <p:sp>
         <p:nvSpPr>
-          <p:cNvPr id="24" name="example_2_icon_line_2"/>
+          <p:cNvPr id="42" name="example_5_icon_line_2"/>
           <p:cNvSpPr/>
           <p:nvPr/>
         </p:nvSpPr>
         <p:spPr>
           <a:xfrm>
-            <a:off x="8209483" y="1767535"/>
+            <a:off x="8209483" y="3824935"/>
             <a:ext cx="148590" cy="20802"/>
           </a:xfrm>
           <a:prstGeom prst="rect">
@@ -11924,13 +12626,13 @@
       </p:sp>
       <p:sp>
         <p:nvSpPr>
-          <p:cNvPr id="25" name="example_2_title"/>
+          <p:cNvPr id="43" name="example_5_title"/>
           <p:cNvSpPr txBox="1"/>
           <p:nvPr/>
         </p:nvSpPr>
         <p:spPr>
           <a:xfrm>
-            <a:off x="8778240" y="1536192"/>
+            <a:off x="8778240" y="3593592"/>
             <a:ext cx="2167128" cy="347472"/>
           </a:xfrm>
           <a:prstGeom prst="rect">
@@ -11947,23 +12649,23 @@
             <a:r>
               <a:rPr sz="1800" b="1">
                 <a:solidFill>
-                  <a:srgbClr val="0F766E"/>
+                  <a:srgbClr val="7C3AED"/>
                 </a:solidFill>
               </a:rPr>
-              <a:t>Pipeline</a:t>
-            </a:r>
-          </a:p>
-        </p:txBody>
-      </p:sp>
-      <p:sp>
-        <p:nvSpPr>
-          <p:cNvPr id="26" name="example_2_body_0"/>
+              <a:t>Theme Preview</a:t>
+            </a:r>
+          </a:p>
+        </p:txBody>
+      </p:sp>
+      <p:sp>
+        <p:nvSpPr>
+          <p:cNvPr id="44" name="example_5_body_0"/>
           <p:cNvSpPr txBox="1"/>
           <p:nvPr/>
         </p:nvSpPr>
         <p:spPr>
           <a:xfrm>
-            <a:off x="8778240" y="1993391"/>
+            <a:off x="8778240" y="4050791"/>
             <a:ext cx="2167128" cy="310896"/>
           </a:xfrm>
           <a:prstGeom prst="rect">
@@ -11983,978 +12685,6 @@
                   <a:srgbClr val="5F6B7A"/>
                 </a:solidFill>
               </a:rPr>
-              <a:t>Pipeline Example</a:t>
-            </a:r>
-          </a:p>
-        </p:txBody>
-      </p:sp>
-      <p:sp>
-        <p:nvSpPr>
-          <p:cNvPr id="27" name="example_2_body_1"/>
-          <p:cNvSpPr txBox="1"/>
-          <p:nvPr/>
-        </p:nvSpPr>
-        <p:spPr>
-          <a:xfrm>
-            <a:off x="8778240" y="2377439"/>
-            <a:ext cx="2167128" cy="310896"/>
-          </a:xfrm>
-          <a:prstGeom prst="rect">
-            <a:avLst/>
-          </a:prstGeom>
-          <a:noFill/>
-        </p:spPr>
-        <p:txBody>
-          <a:bodyPr wrap="square" anchor="ctr" lIns="0" rIns="0" tIns="0" bIns="0">
-            <a:spAutoFit/>
-          </a:bodyPr>
-          <a:lstStyle/>
-          <a:p>
-            <a:r>
-              <a:rPr sz="1600" b="0">
-                <a:solidFill>
-                  <a:srgbClr val="5F6B7A"/>
-                </a:solidFill>
-              </a:rPr>
-              <a:t>3 headings · 186 chars</a:t>
-            </a:r>
-          </a:p>
-        </p:txBody>
-      </p:sp>
-      <p:sp>
-        <p:nvSpPr>
-          <p:cNvPr id="28" name="example_3_card"/>
-          <p:cNvSpPr/>
-          <p:nvPr/>
-        </p:nvSpPr>
-        <p:spPr>
-          <a:xfrm>
-            <a:off x="658368" y="3410712"/>
-            <a:ext cx="3154680" cy="1737360"/>
-          </a:xfrm>
-          <a:prstGeom prst="roundRect">
-            <a:avLst/>
-          </a:prstGeom>
-          <a:solidFill>
-            <a:srgbClr val="FFFDF8"/>
-          </a:solidFill>
-          <a:ln>
-            <a:solidFill>
-              <a:srgbClr val="D7CDBD"/>
-            </a:solidFill>
-          </a:ln>
-        </p:spPr>
-        <p:style>
-          <a:lnRef idx="1">
-            <a:schemeClr val="accent1"/>
-          </a:lnRef>
-          <a:fillRef idx="3">
-            <a:schemeClr val="accent1"/>
-          </a:fillRef>
-          <a:effectRef idx="2">
-            <a:schemeClr val="accent1"/>
-          </a:effectRef>
-          <a:fontRef idx="minor">
-            <a:schemeClr val="lt1"/>
-          </a:fontRef>
-        </p:style>
-        <p:txBody>
-          <a:bodyPr rtlCol="0" anchor="ctr"/>
-          <a:lstStyle/>
-          <a:p>
-            <a:pPr algn="ctr"/>
-          </a:p>
-        </p:txBody>
-      </p:sp>
-      <p:sp>
-        <p:nvSpPr>
-          <p:cNvPr id="29" name="example_3_icon_doc"/>
-          <p:cNvSpPr/>
-          <p:nvPr/>
-        </p:nvSpPr>
-        <p:spPr>
-          <a:xfrm>
-            <a:off x="822959" y="3575304"/>
-            <a:ext cx="285292" cy="368503"/>
-          </a:xfrm>
-          <a:prstGeom prst="roundRect">
-            <a:avLst/>
-          </a:prstGeom>
-          <a:solidFill>
-            <a:srgbClr val="111827"/>
-          </a:solidFill>
-          <a:ln>
-            <a:solidFill>
-              <a:srgbClr val="111827"/>
-            </a:solidFill>
-          </a:ln>
-        </p:spPr>
-        <p:style>
-          <a:lnRef idx="1">
-            <a:schemeClr val="accent1"/>
-          </a:lnRef>
-          <a:fillRef idx="3">
-            <a:schemeClr val="accent1"/>
-          </a:fillRef>
-          <a:effectRef idx="2">
-            <a:schemeClr val="accent1"/>
-          </a:effectRef>
-          <a:fontRef idx="minor">
-            <a:schemeClr val="lt1"/>
-          </a:fontRef>
-        </p:style>
-        <p:txBody>
-          <a:bodyPr rtlCol="0" anchor="ctr"/>
-          <a:lstStyle/>
-          <a:p>
-            <a:pPr algn="ctr"/>
-          </a:p>
-        </p:txBody>
-      </p:sp>
-      <p:sp>
-        <p:nvSpPr>
-          <p:cNvPr id="30" name="example_3_icon_line_0"/>
-          <p:cNvSpPr/>
-          <p:nvPr/>
-        </p:nvSpPr>
-        <p:spPr>
-          <a:xfrm>
-            <a:off x="894283" y="3670401"/>
-            <a:ext cx="148590" cy="20802"/>
-          </a:xfrm>
-          <a:prstGeom prst="rect">
-            <a:avLst/>
-          </a:prstGeom>
-          <a:solidFill>
-            <a:srgbClr val="F7F2EA"/>
-          </a:solidFill>
-          <a:ln>
-            <a:solidFill>
-              <a:srgbClr val="F7F2EA"/>
-            </a:solidFill>
-          </a:ln>
-        </p:spPr>
-        <p:style>
-          <a:lnRef idx="1">
-            <a:schemeClr val="accent1"/>
-          </a:lnRef>
-          <a:fillRef idx="3">
-            <a:schemeClr val="accent1"/>
-          </a:fillRef>
-          <a:effectRef idx="2">
-            <a:schemeClr val="accent1"/>
-          </a:effectRef>
-          <a:fontRef idx="minor">
-            <a:schemeClr val="lt1"/>
-          </a:fontRef>
-        </p:style>
-        <p:txBody>
-          <a:bodyPr rtlCol="0" anchor="ctr"/>
-          <a:lstStyle/>
-          <a:p>
-            <a:pPr algn="ctr"/>
-          </a:p>
-        </p:txBody>
-      </p:sp>
-      <p:sp>
-        <p:nvSpPr>
-          <p:cNvPr id="31" name="example_3_icon_line_1"/>
-          <p:cNvSpPr/>
-          <p:nvPr/>
-        </p:nvSpPr>
-        <p:spPr>
-          <a:xfrm>
-            <a:off x="894283" y="3747668"/>
-            <a:ext cx="148590" cy="20802"/>
-          </a:xfrm>
-          <a:prstGeom prst="rect">
-            <a:avLst/>
-          </a:prstGeom>
-          <a:solidFill>
-            <a:srgbClr val="F7F2EA"/>
-          </a:solidFill>
-          <a:ln>
-            <a:solidFill>
-              <a:srgbClr val="F7F2EA"/>
-            </a:solidFill>
-          </a:ln>
-        </p:spPr>
-        <p:style>
-          <a:lnRef idx="1">
-            <a:schemeClr val="accent1"/>
-          </a:lnRef>
-          <a:fillRef idx="3">
-            <a:schemeClr val="accent1"/>
-          </a:fillRef>
-          <a:effectRef idx="2">
-            <a:schemeClr val="accent1"/>
-          </a:effectRef>
-          <a:fontRef idx="minor">
-            <a:schemeClr val="lt1"/>
-          </a:fontRef>
-        </p:style>
-        <p:txBody>
-          <a:bodyPr rtlCol="0" anchor="ctr"/>
-          <a:lstStyle/>
-          <a:p>
-            <a:pPr algn="ctr"/>
-          </a:p>
-        </p:txBody>
-      </p:sp>
-      <p:sp>
-        <p:nvSpPr>
-          <p:cNvPr id="32" name="example_3_icon_line_2"/>
-          <p:cNvSpPr/>
-          <p:nvPr/>
-        </p:nvSpPr>
-        <p:spPr>
-          <a:xfrm>
-            <a:off x="894283" y="3824935"/>
-            <a:ext cx="148590" cy="20802"/>
-          </a:xfrm>
-          <a:prstGeom prst="rect">
-            <a:avLst/>
-          </a:prstGeom>
-          <a:solidFill>
-            <a:srgbClr val="F7F2EA"/>
-          </a:solidFill>
-          <a:ln>
-            <a:solidFill>
-              <a:srgbClr val="F7F2EA"/>
-            </a:solidFill>
-          </a:ln>
-        </p:spPr>
-        <p:style>
-          <a:lnRef idx="1">
-            <a:schemeClr val="accent1"/>
-          </a:lnRef>
-          <a:fillRef idx="3">
-            <a:schemeClr val="accent1"/>
-          </a:fillRef>
-          <a:effectRef idx="2">
-            <a:schemeClr val="accent1"/>
-          </a:effectRef>
-          <a:fontRef idx="minor">
-            <a:schemeClr val="lt1"/>
-          </a:fontRef>
-        </p:style>
-        <p:txBody>
-          <a:bodyPr rtlCol="0" anchor="ctr"/>
-          <a:lstStyle/>
-          <a:p>
-            <a:pPr algn="ctr"/>
-          </a:p>
-        </p:txBody>
-      </p:sp>
-      <p:sp>
-        <p:nvSpPr>
-          <p:cNvPr id="33" name="example_3_title"/>
-          <p:cNvSpPr txBox="1"/>
-          <p:nvPr/>
-        </p:nvSpPr>
-        <p:spPr>
-          <a:xfrm>
-            <a:off x="1463040" y="3593592"/>
-            <a:ext cx="2167128" cy="347472"/>
-          </a:xfrm>
-          <a:prstGeom prst="rect">
-            <a:avLst/>
-          </a:prstGeom>
-          <a:noFill/>
-        </p:spPr>
-        <p:txBody>
-          <a:bodyPr wrap="square" anchor="ctr" lIns="0" rIns="0" tIns="0" bIns="0">
-            <a:spAutoFit/>
-          </a:bodyPr>
-          <a:lstStyle/>
-          <a:p>
-            <a:r>
-              <a:rPr sz="1800" b="1">
-                <a:solidFill>
-                  <a:srgbClr val="7C3AED"/>
-                </a:solidFill>
-              </a:rPr>
-              <a:t>Diagram</a:t>
-            </a:r>
-          </a:p>
-        </p:txBody>
-      </p:sp>
-      <p:sp>
-        <p:nvSpPr>
-          <p:cNvPr id="34" name="example_3_body_0"/>
-          <p:cNvSpPr txBox="1"/>
-          <p:nvPr/>
-        </p:nvSpPr>
-        <p:spPr>
-          <a:xfrm>
-            <a:off x="1463040" y="4050791"/>
-            <a:ext cx="2167128" cy="310896"/>
-          </a:xfrm>
-          <a:prstGeom prst="rect">
-            <a:avLst/>
-          </a:prstGeom>
-          <a:noFill/>
-        </p:spPr>
-        <p:txBody>
-          <a:bodyPr wrap="square" anchor="ctr" lIns="0" rIns="0" tIns="0" bIns="0">
-            <a:spAutoFit/>
-          </a:bodyPr>
-          <a:lstStyle/>
-          <a:p>
-            <a:r>
-              <a:rPr sz="1600" b="0">
-                <a:solidFill>
-                  <a:srgbClr val="5F6B7A"/>
-                </a:solidFill>
-              </a:rPr>
-              <a:t>Diagram Arrangement Examples</a:t>
-            </a:r>
-          </a:p>
-        </p:txBody>
-      </p:sp>
-      <p:sp>
-        <p:nvSpPr>
-          <p:cNvPr id="35" name="example_3_body_1"/>
-          <p:cNvSpPr txBox="1"/>
-          <p:nvPr/>
-        </p:nvSpPr>
-        <p:spPr>
-          <a:xfrm>
-            <a:off x="1463040" y="4434840"/>
-            <a:ext cx="2167128" cy="310896"/>
-          </a:xfrm>
-          <a:prstGeom prst="rect">
-            <a:avLst/>
-          </a:prstGeom>
-          <a:noFill/>
-        </p:spPr>
-        <p:txBody>
-          <a:bodyPr wrap="square" anchor="ctr" lIns="0" rIns="0" tIns="0" bIns="0">
-            <a:spAutoFit/>
-          </a:bodyPr>
-          <a:lstStyle/>
-          <a:p>
-            <a:r>
-              <a:rPr sz="1600" b="0">
-                <a:solidFill>
-                  <a:srgbClr val="5F6B7A"/>
-                </a:solidFill>
-              </a:rPr>
-              <a:t>6 headings · 457 chars</a:t>
-            </a:r>
-          </a:p>
-        </p:txBody>
-      </p:sp>
-      <p:sp>
-        <p:nvSpPr>
-          <p:cNvPr id="36" name="example_4_card"/>
-          <p:cNvSpPr/>
-          <p:nvPr/>
-        </p:nvSpPr>
-        <p:spPr>
-          <a:xfrm>
-            <a:off x="4315968" y="3410712"/>
-            <a:ext cx="3154680" cy="1737360"/>
-          </a:xfrm>
-          <a:prstGeom prst="roundRect">
-            <a:avLst/>
-          </a:prstGeom>
-          <a:solidFill>
-            <a:srgbClr val="FFFDF8"/>
-          </a:solidFill>
-          <a:ln>
-            <a:solidFill>
-              <a:srgbClr val="D7CDBD"/>
-            </a:solidFill>
-          </a:ln>
-        </p:spPr>
-        <p:style>
-          <a:lnRef idx="1">
-            <a:schemeClr val="accent1"/>
-          </a:lnRef>
-          <a:fillRef idx="3">
-            <a:schemeClr val="accent1"/>
-          </a:fillRef>
-          <a:effectRef idx="2">
-            <a:schemeClr val="accent1"/>
-          </a:effectRef>
-          <a:fontRef idx="minor">
-            <a:schemeClr val="lt1"/>
-          </a:fontRef>
-        </p:style>
-        <p:txBody>
-          <a:bodyPr rtlCol="0" anchor="ctr"/>
-          <a:lstStyle/>
-          <a:p>
-            <a:pPr algn="ctr"/>
-          </a:p>
-        </p:txBody>
-      </p:sp>
-      <p:sp>
-        <p:nvSpPr>
-          <p:cNvPr id="37" name="example_4_icon_doc"/>
-          <p:cNvSpPr/>
-          <p:nvPr/>
-        </p:nvSpPr>
-        <p:spPr>
-          <a:xfrm>
-            <a:off x="4480559" y="3575304"/>
-            <a:ext cx="285292" cy="368503"/>
-          </a:xfrm>
-          <a:prstGeom prst="roundRect">
-            <a:avLst/>
-          </a:prstGeom>
-          <a:solidFill>
-            <a:srgbClr val="111827"/>
-          </a:solidFill>
-          <a:ln>
-            <a:solidFill>
-              <a:srgbClr val="111827"/>
-            </a:solidFill>
-          </a:ln>
-        </p:spPr>
-        <p:style>
-          <a:lnRef idx="1">
-            <a:schemeClr val="accent1"/>
-          </a:lnRef>
-          <a:fillRef idx="3">
-            <a:schemeClr val="accent1"/>
-          </a:fillRef>
-          <a:effectRef idx="2">
-            <a:schemeClr val="accent1"/>
-          </a:effectRef>
-          <a:fontRef idx="minor">
-            <a:schemeClr val="lt1"/>
-          </a:fontRef>
-        </p:style>
-        <p:txBody>
-          <a:bodyPr rtlCol="0" anchor="ctr"/>
-          <a:lstStyle/>
-          <a:p>
-            <a:pPr algn="ctr"/>
-          </a:p>
-        </p:txBody>
-      </p:sp>
-      <p:sp>
-        <p:nvSpPr>
-          <p:cNvPr id="38" name="example_4_icon_line_0"/>
-          <p:cNvSpPr/>
-          <p:nvPr/>
-        </p:nvSpPr>
-        <p:spPr>
-          <a:xfrm>
-            <a:off x="4551883" y="3670401"/>
-            <a:ext cx="148590" cy="20802"/>
-          </a:xfrm>
-          <a:prstGeom prst="rect">
-            <a:avLst/>
-          </a:prstGeom>
-          <a:solidFill>
-            <a:srgbClr val="F7F2EA"/>
-          </a:solidFill>
-          <a:ln>
-            <a:solidFill>
-              <a:srgbClr val="F7F2EA"/>
-            </a:solidFill>
-          </a:ln>
-        </p:spPr>
-        <p:style>
-          <a:lnRef idx="1">
-            <a:schemeClr val="accent1"/>
-          </a:lnRef>
-          <a:fillRef idx="3">
-            <a:schemeClr val="accent1"/>
-          </a:fillRef>
-          <a:effectRef idx="2">
-            <a:schemeClr val="accent1"/>
-          </a:effectRef>
-          <a:fontRef idx="minor">
-            <a:schemeClr val="lt1"/>
-          </a:fontRef>
-        </p:style>
-        <p:txBody>
-          <a:bodyPr rtlCol="0" anchor="ctr"/>
-          <a:lstStyle/>
-          <a:p>
-            <a:pPr algn="ctr"/>
-          </a:p>
-        </p:txBody>
-      </p:sp>
-      <p:sp>
-        <p:nvSpPr>
-          <p:cNvPr id="39" name="example_4_icon_line_1"/>
-          <p:cNvSpPr/>
-          <p:nvPr/>
-        </p:nvSpPr>
-        <p:spPr>
-          <a:xfrm>
-            <a:off x="4551883" y="3747668"/>
-            <a:ext cx="148590" cy="20802"/>
-          </a:xfrm>
-          <a:prstGeom prst="rect">
-            <a:avLst/>
-          </a:prstGeom>
-          <a:solidFill>
-            <a:srgbClr val="F7F2EA"/>
-          </a:solidFill>
-          <a:ln>
-            <a:solidFill>
-              <a:srgbClr val="F7F2EA"/>
-            </a:solidFill>
-          </a:ln>
-        </p:spPr>
-        <p:style>
-          <a:lnRef idx="1">
-            <a:schemeClr val="accent1"/>
-          </a:lnRef>
-          <a:fillRef idx="3">
-            <a:schemeClr val="accent1"/>
-          </a:fillRef>
-          <a:effectRef idx="2">
-            <a:schemeClr val="accent1"/>
-          </a:effectRef>
-          <a:fontRef idx="minor">
-            <a:schemeClr val="lt1"/>
-          </a:fontRef>
-        </p:style>
-        <p:txBody>
-          <a:bodyPr rtlCol="0" anchor="ctr"/>
-          <a:lstStyle/>
-          <a:p>
-            <a:pPr algn="ctr"/>
-          </a:p>
-        </p:txBody>
-      </p:sp>
-      <p:sp>
-        <p:nvSpPr>
-          <p:cNvPr id="40" name="example_4_icon_line_2"/>
-          <p:cNvSpPr/>
-          <p:nvPr/>
-        </p:nvSpPr>
-        <p:spPr>
-          <a:xfrm>
-            <a:off x="4551883" y="3824935"/>
-            <a:ext cx="148590" cy="20802"/>
-          </a:xfrm>
-          <a:prstGeom prst="rect">
-            <a:avLst/>
-          </a:prstGeom>
-          <a:solidFill>
-            <a:srgbClr val="F7F2EA"/>
-          </a:solidFill>
-          <a:ln>
-            <a:solidFill>
-              <a:srgbClr val="F7F2EA"/>
-            </a:solidFill>
-          </a:ln>
-        </p:spPr>
-        <p:style>
-          <a:lnRef idx="1">
-            <a:schemeClr val="accent1"/>
-          </a:lnRef>
-          <a:fillRef idx="3">
-            <a:schemeClr val="accent1"/>
-          </a:fillRef>
-          <a:effectRef idx="2">
-            <a:schemeClr val="accent1"/>
-          </a:effectRef>
-          <a:fontRef idx="minor">
-            <a:schemeClr val="lt1"/>
-          </a:fontRef>
-        </p:style>
-        <p:txBody>
-          <a:bodyPr rtlCol="0" anchor="ctr"/>
-          <a:lstStyle/>
-          <a:p>
-            <a:pPr algn="ctr"/>
-          </a:p>
-        </p:txBody>
-      </p:sp>
-      <p:sp>
-        <p:nvSpPr>
-          <p:cNvPr id="41" name="example_4_title"/>
-          <p:cNvSpPr txBox="1"/>
-          <p:nvPr/>
-        </p:nvSpPr>
-        <p:spPr>
-          <a:xfrm>
-            <a:off x="5120640" y="3593592"/>
-            <a:ext cx="2167128" cy="347472"/>
-          </a:xfrm>
-          <a:prstGeom prst="rect">
-            <a:avLst/>
-          </a:prstGeom>
-          <a:noFill/>
-        </p:spPr>
-        <p:txBody>
-          <a:bodyPr wrap="square" anchor="ctr" lIns="0" rIns="0" tIns="0" bIns="0">
-            <a:spAutoFit/>
-          </a:bodyPr>
-          <a:lstStyle/>
-          <a:p>
-            <a:r>
-              <a:rPr sz="1800" b="1">
-                <a:solidFill>
-                  <a:srgbClr val="0F766E"/>
-                </a:solidFill>
-              </a:rPr>
-              <a:t>Five Methods</a:t>
-            </a:r>
-          </a:p>
-        </p:txBody>
-      </p:sp>
-      <p:sp>
-        <p:nvSpPr>
-          <p:cNvPr id="42" name="example_4_body_0"/>
-          <p:cNvSpPr txBox="1"/>
-          <p:nvPr/>
-        </p:nvSpPr>
-        <p:spPr>
-          <a:xfrm>
-            <a:off x="5120640" y="4050791"/>
-            <a:ext cx="2167128" cy="310896"/>
-          </a:xfrm>
-          <a:prstGeom prst="rect">
-            <a:avLst/>
-          </a:prstGeom>
-          <a:noFill/>
-        </p:spPr>
-        <p:txBody>
-          <a:bodyPr wrap="square" anchor="ctr" lIns="0" rIns="0" tIns="0" bIns="0">
-            <a:spAutoFit/>
-          </a:bodyPr>
-          <a:lstStyle/>
-          <a:p>
-            <a:r>
-              <a:rPr sz="1600" b="0">
-                <a:solidFill>
-                  <a:srgbClr val="5F6B7A"/>
-                </a:solidFill>
-              </a:rPr>
-              <a:t>Five-Item Layout Example</a:t>
-            </a:r>
-          </a:p>
-        </p:txBody>
-      </p:sp>
-      <p:sp>
-        <p:nvSpPr>
-          <p:cNvPr id="43" name="example_4_body_1"/>
-          <p:cNvSpPr txBox="1"/>
-          <p:nvPr/>
-        </p:nvSpPr>
-        <p:spPr>
-          <a:xfrm>
-            <a:off x="5120640" y="4434840"/>
-            <a:ext cx="2167128" cy="310896"/>
-          </a:xfrm>
-          <a:prstGeom prst="rect">
-            <a:avLst/>
-          </a:prstGeom>
-          <a:noFill/>
-        </p:spPr>
-        <p:txBody>
-          <a:bodyPr wrap="square" anchor="ctr" lIns="0" rIns="0" tIns="0" bIns="0">
-            <a:spAutoFit/>
-          </a:bodyPr>
-          <a:lstStyle/>
-          <a:p>
-            <a:r>
-              <a:rPr sz="1600" b="0">
-                <a:solidFill>
-                  <a:srgbClr val="5F6B7A"/>
-                </a:solidFill>
-              </a:rPr>
-              <a:t>2 headings · 200 chars</a:t>
-            </a:r>
-          </a:p>
-        </p:txBody>
-      </p:sp>
-      <p:sp>
-        <p:nvSpPr>
-          <p:cNvPr id="44" name="example_5_card"/>
-          <p:cNvSpPr/>
-          <p:nvPr/>
-        </p:nvSpPr>
-        <p:spPr>
-          <a:xfrm>
-            <a:off x="7973568" y="3410712"/>
-            <a:ext cx="3154680" cy="1737360"/>
-          </a:xfrm>
-          <a:prstGeom prst="roundRect">
-            <a:avLst/>
-          </a:prstGeom>
-          <a:solidFill>
-            <a:srgbClr val="FFFDF8"/>
-          </a:solidFill>
-          <a:ln>
-            <a:solidFill>
-              <a:srgbClr val="D7CDBD"/>
-            </a:solidFill>
-          </a:ln>
-        </p:spPr>
-        <p:style>
-          <a:lnRef idx="1">
-            <a:schemeClr val="accent1"/>
-          </a:lnRef>
-          <a:fillRef idx="3">
-            <a:schemeClr val="accent1"/>
-          </a:fillRef>
-          <a:effectRef idx="2">
-            <a:schemeClr val="accent1"/>
-          </a:effectRef>
-          <a:fontRef idx="minor">
-            <a:schemeClr val="lt1"/>
-          </a:fontRef>
-        </p:style>
-        <p:txBody>
-          <a:bodyPr rtlCol="0" anchor="ctr"/>
-          <a:lstStyle/>
-          <a:p>
-            <a:pPr algn="ctr"/>
-          </a:p>
-        </p:txBody>
-      </p:sp>
-      <p:sp>
-        <p:nvSpPr>
-          <p:cNvPr id="45" name="example_5_icon_doc"/>
-          <p:cNvSpPr/>
-          <p:nvPr/>
-        </p:nvSpPr>
-        <p:spPr>
-          <a:xfrm>
-            <a:off x="8138160" y="3575304"/>
-            <a:ext cx="285292" cy="368503"/>
-          </a:xfrm>
-          <a:prstGeom prst="roundRect">
-            <a:avLst/>
-          </a:prstGeom>
-          <a:solidFill>
-            <a:srgbClr val="111827"/>
-          </a:solidFill>
-          <a:ln>
-            <a:solidFill>
-              <a:srgbClr val="111827"/>
-            </a:solidFill>
-          </a:ln>
-        </p:spPr>
-        <p:style>
-          <a:lnRef idx="1">
-            <a:schemeClr val="accent1"/>
-          </a:lnRef>
-          <a:fillRef idx="3">
-            <a:schemeClr val="accent1"/>
-          </a:fillRef>
-          <a:effectRef idx="2">
-            <a:schemeClr val="accent1"/>
-          </a:effectRef>
-          <a:fontRef idx="minor">
-            <a:schemeClr val="lt1"/>
-          </a:fontRef>
-        </p:style>
-        <p:txBody>
-          <a:bodyPr rtlCol="0" anchor="ctr"/>
-          <a:lstStyle/>
-          <a:p>
-            <a:pPr algn="ctr"/>
-          </a:p>
-        </p:txBody>
-      </p:sp>
-      <p:sp>
-        <p:nvSpPr>
-          <p:cNvPr id="46" name="example_5_icon_line_0"/>
-          <p:cNvSpPr/>
-          <p:nvPr/>
-        </p:nvSpPr>
-        <p:spPr>
-          <a:xfrm>
-            <a:off x="8209483" y="3670401"/>
-            <a:ext cx="148590" cy="20802"/>
-          </a:xfrm>
-          <a:prstGeom prst="rect">
-            <a:avLst/>
-          </a:prstGeom>
-          <a:solidFill>
-            <a:srgbClr val="F7F2EA"/>
-          </a:solidFill>
-          <a:ln>
-            <a:solidFill>
-              <a:srgbClr val="F7F2EA"/>
-            </a:solidFill>
-          </a:ln>
-        </p:spPr>
-        <p:style>
-          <a:lnRef idx="1">
-            <a:schemeClr val="accent1"/>
-          </a:lnRef>
-          <a:fillRef idx="3">
-            <a:schemeClr val="accent1"/>
-          </a:fillRef>
-          <a:effectRef idx="2">
-            <a:schemeClr val="accent1"/>
-          </a:effectRef>
-          <a:fontRef idx="minor">
-            <a:schemeClr val="lt1"/>
-          </a:fontRef>
-        </p:style>
-        <p:txBody>
-          <a:bodyPr rtlCol="0" anchor="ctr"/>
-          <a:lstStyle/>
-          <a:p>
-            <a:pPr algn="ctr"/>
-          </a:p>
-        </p:txBody>
-      </p:sp>
-      <p:sp>
-        <p:nvSpPr>
-          <p:cNvPr id="47" name="example_5_icon_line_1"/>
-          <p:cNvSpPr/>
-          <p:nvPr/>
-        </p:nvSpPr>
-        <p:spPr>
-          <a:xfrm>
-            <a:off x="8209483" y="3747668"/>
-            <a:ext cx="148590" cy="20802"/>
-          </a:xfrm>
-          <a:prstGeom prst="rect">
-            <a:avLst/>
-          </a:prstGeom>
-          <a:solidFill>
-            <a:srgbClr val="F7F2EA"/>
-          </a:solidFill>
-          <a:ln>
-            <a:solidFill>
-              <a:srgbClr val="F7F2EA"/>
-            </a:solidFill>
-          </a:ln>
-        </p:spPr>
-        <p:style>
-          <a:lnRef idx="1">
-            <a:schemeClr val="accent1"/>
-          </a:lnRef>
-          <a:fillRef idx="3">
-            <a:schemeClr val="accent1"/>
-          </a:fillRef>
-          <a:effectRef idx="2">
-            <a:schemeClr val="accent1"/>
-          </a:effectRef>
-          <a:fontRef idx="minor">
-            <a:schemeClr val="lt1"/>
-          </a:fontRef>
-        </p:style>
-        <p:txBody>
-          <a:bodyPr rtlCol="0" anchor="ctr"/>
-          <a:lstStyle/>
-          <a:p>
-            <a:pPr algn="ctr"/>
-          </a:p>
-        </p:txBody>
-      </p:sp>
-      <p:sp>
-        <p:nvSpPr>
-          <p:cNvPr id="48" name="example_5_icon_line_2"/>
-          <p:cNvSpPr/>
-          <p:nvPr/>
-        </p:nvSpPr>
-        <p:spPr>
-          <a:xfrm>
-            <a:off x="8209483" y="3824935"/>
-            <a:ext cx="148590" cy="20802"/>
-          </a:xfrm>
-          <a:prstGeom prst="rect">
-            <a:avLst/>
-          </a:prstGeom>
-          <a:solidFill>
-            <a:srgbClr val="F7F2EA"/>
-          </a:solidFill>
-          <a:ln>
-            <a:solidFill>
-              <a:srgbClr val="F7F2EA"/>
-            </a:solidFill>
-          </a:ln>
-        </p:spPr>
-        <p:style>
-          <a:lnRef idx="1">
-            <a:schemeClr val="accent1"/>
-          </a:lnRef>
-          <a:fillRef idx="3">
-            <a:schemeClr val="accent1"/>
-          </a:fillRef>
-          <a:effectRef idx="2">
-            <a:schemeClr val="accent1"/>
-          </a:effectRef>
-          <a:fontRef idx="minor">
-            <a:schemeClr val="lt1"/>
-          </a:fontRef>
-        </p:style>
-        <p:txBody>
-          <a:bodyPr rtlCol="0" anchor="ctr"/>
-          <a:lstStyle/>
-          <a:p>
-            <a:pPr algn="ctr"/>
-          </a:p>
-        </p:txBody>
-      </p:sp>
-      <p:sp>
-        <p:nvSpPr>
-          <p:cNvPr id="49" name="example_5_title"/>
-          <p:cNvSpPr txBox="1"/>
-          <p:nvPr/>
-        </p:nvSpPr>
-        <p:spPr>
-          <a:xfrm>
-            <a:off x="8778240" y="3593592"/>
-            <a:ext cx="2167128" cy="347472"/>
-          </a:xfrm>
-          <a:prstGeom prst="rect">
-            <a:avLst/>
-          </a:prstGeom>
-          <a:noFill/>
-        </p:spPr>
-        <p:txBody>
-          <a:bodyPr wrap="square" anchor="ctr" lIns="0" rIns="0" tIns="0" bIns="0">
-            <a:spAutoFit/>
-          </a:bodyPr>
-          <a:lstStyle/>
-          <a:p>
-            <a:r>
-              <a:rPr sz="1800" b="1">
-                <a:solidFill>
-                  <a:srgbClr val="7C3AED"/>
-                </a:solidFill>
-              </a:rPr>
-              <a:t>Theme Preview</a:t>
-            </a:r>
-          </a:p>
-        </p:txBody>
-      </p:sp>
-      <p:sp>
-        <p:nvSpPr>
-          <p:cNvPr id="50" name="example_5_body_0"/>
-          <p:cNvSpPr txBox="1"/>
-          <p:nvPr/>
-        </p:nvSpPr>
-        <p:spPr>
-          <a:xfrm>
-            <a:off x="8778240" y="4050791"/>
-            <a:ext cx="2167128" cy="310896"/>
-          </a:xfrm>
-          <a:prstGeom prst="rect">
-            <a:avLst/>
-          </a:prstGeom>
-          <a:noFill/>
-        </p:spPr>
-        <p:txBody>
-          <a:bodyPr wrap="square" anchor="ctr" lIns="0" rIns="0" tIns="0" bIns="0">
-            <a:spAutoFit/>
-          </a:bodyPr>
-          <a:lstStyle/>
-          <a:p>
-            <a:r>
-              <a:rPr sz="1600" b="0">
-                <a:solidFill>
-                  <a:srgbClr val="5F6B7A"/>
-                </a:solidFill>
-              </a:rPr>
               <a:t>MDPR Design Grammar</a:t>
             </a:r>
           </a:p>
@@ -12962,7 +12692,7 @@
       </p:sp>
       <p:sp>
         <p:nvSpPr>
-          <p:cNvPr id="51" name="example_5_body_1"/>
+          <p:cNvPr id="45" name="example_5_body_1"/>
           <p:cNvSpPr txBox="1"/>
           <p:nvPr/>
         </p:nvSpPr>

</xml_diff>

<commit_message>
Disambiguate source evidence sample labels
Show the shortest unique source-relative suffix only when sampled source basenames collide. Preserve unique labels and source order, fail closed on unsafe or irreducibly duplicate paths, and record the fifth bounded Pro review with RGB before/current-render evidence.
</commit_message>
<xml_diff>
--- a/artifacts/mdpr-vs-skill/mdpr-skill-from-actual-md-run.pptx
+++ b/artifacts/mdpr-vs-skill/mdpr-skill-from-actual-md-run.pptx
@@ -5598,7 +5598,7 @@
                   <a:srgbClr val="5F6B7A"/>
                 </a:solidFill>
               </a:rPr>
-              <a:t>deck.md</a:t>
+              <a:t>basic/deck.md</a:t>
             </a:r>
           </a:p>
         </p:txBody>
@@ -5631,7 +5631,7 @@
                   <a:srgbClr val="5F6B7A"/>
                 </a:solidFill>
               </a:rPr>
-              <a:t>deck.md</a:t>
+              <a:t>comparison/deck.md</a:t>
             </a:r>
           </a:p>
         </p:txBody>
@@ -5664,7 +5664,7 @@
                   <a:srgbClr val="5F6B7A"/>
                 </a:solidFill>
               </a:rPr>
-              <a:t>deck.md</a:t>
+              <a:t>pipeline/deck.md</a:t>
             </a:r>
           </a:p>
         </p:txBody>

</xml_diff>